<commit_message>
E8 V-term ablation results (AIME, 70%: no V term beats attention mass; projected V r32/16/8 lowest); docs, slide source and deck updated
Co-Authored-By: Claude Opus 5.5 <noreply@anthropic.com>
</commit_message>
<xml_diff>
--- a/results/m1_m2_m3_frontier_v27_20260929/ppt_sample/dlm_sparse_attention_20261001.pptx
+++ b/results/m1_m2_m3_frontier_v27_20260929/ppt_sample/dlm_sparse_attention_20261001.pptx
@@ -13,6 +13,7 @@
     <p:sldId id="261" r:id="rId13"/>
     <p:sldId id="262" r:id="rId14"/>
     <p:sldId id="263" r:id="rId15"/>
+    <p:sldId id="264" r:id="rId16"/>
   </p:sldIdLst>
   <p:sldSz cx="12191695" cy="6858000" type="screen4x3"/>
   <p:notesSz cx="6858000" cy="9144000"/>
@@ -934,27 +935,27 @@
           <a:lstStyle/>
           <a:p>
             <a:r>
-              <a:t>【每步构成】（32K dense，substrate/time_breakdown.json，v2 时期，KV 拼接已在 v3 去掉）forward 约 32 ms：MoE 专家矩阵乘 12.8 ms、GLOBAL 注意力 7.2 ms、其余矩阵乘 3.5 ms、LOCAL 0.8 ms、其他约 4 ms；另有采样约 4.6 ms。</a:t>
-            </a:r>
-          </a:p>
-          <a:p>
-            <a:r>
-              <a:t>【MoE】128 个专家、每 token 选 8 个；一步 256 个 canvas token × 8 = 2048 次分配，几乎所有专家都会被用到，所以每步要读全部专家权重（约 46 GB），12.8 ms 已接近 H100 的 HBM 带宽极限。</a:t>
-            </a:r>
-          </a:p>
-          <a:p>
-            <a:r>
-              <a:t>【GLOBAL 注意力】CUDA event 直接计时（kernel_bench/module_profile_*）：dense 每层 1.46 ms（32K）/ 2.95 ms（64K）；M3 R6 DP −ln2 摊到每步：32K 4.3 ms、64K 5.5 ms（dense 7.3 / 14.75 ms）。</a:t>
-            </a:r>
-          </a:p>
-          <a:p>
-            <a:r>
-              <a:t>【每步解码时间】（摊销，72 格平均）32K dense 37.3 ms、M3 34.7、B 33.5；64K dense 45.3、M3 37.2、B 36.1；AIME dense 30.7、M3 31.4。</a:t>
-            </a:r>
-          </a:p>
-          <a:p>
-            <a:r>
-              <a:t>【还能挖的】canvas 追加（encoder 与 decoder 共享权重，可复用最后的选块图）约 −1.4%（64K）；剩余观测/决策开销约 −1–2%。</a:t>
+              <a:t>【协议】v27_aime_vterm_e8_bd293196ff730851（specs/v27_aime_vterm_e8.json），部署 v27_e8_021431b；1,440/1,440 次运行成功，每格同机，3 次计时中出现新图；dense 输出与 E7 逐 token 相同（180/180）。</a:t>
+            </a:r>
+          </a:p>
+          <a:p>
+            <a:r>
+              <a:t>【收据核对】每次运行的 effective_method 都是预定配置：risk_topk k30；proj_rank 32/16/8/4；risk_value=mass；M2 为 pooled_compact（54,105 次块均值构建）。</a:t>
+            </a:r>
+          </a:p>
+          <a:p>
+            <a:r>
+              <a:t>【速度】70% 稀疏时我们的选块器步数多 6–13%、输出长 2–9%，端到端慢 7–17%；AIME 本身没有速度空间。</a:t>
+            </a:r>
+          </a:p>
+          <a:p>
+            <a:r>
+              <a:t>【组内对照】JunyuLiao 在 RULER8K 上发现 V 有用；他的选块用当前 QK，我们用历史 QK，任务也不同。只引用。</a:t>
+            </a:r>
+          </a:p>
+          <a:p>
+            <a:r>
+              <a:t>【数据路径】results/m1_m2_m3_frontier_v27_20260929/aime_vterm_panel_e8/summary.md、receipts.md</a:t>
             </a:r>
           </a:p>
         </p:txBody>
@@ -1024,17 +1025,27 @@
           <a:lstStyle/>
           <a:p>
             <a:r>
-              <a:t>【脚本】scripts/v27_batch_step_bench.py（提交 02eead519），dlm2，E4 运行目录与部署；数据 results/m1_m2_m3_frontier_v27_20260929/batch_scaling/。</a:t>
-            </a:r>
-          </a:p>
-          <a:p>
-            <a:r>
-              <a:t>【口径】eager 的整次 decoder forward（含每次调用的 K/V 拼接，1.2/2.4/4.7 ms）一次性 CUDA graph 捕获后重放，CUDA event 取 15 次中位数；采样另测 2.5/4.8/9.4 ms。</a:t>
-            </a:r>
-          </a:p>
-          <a:p>
-            <a:r>
-              <a:t>【局限】只测了 64K 一个状态；batch 8 时复制的 64K 缓存放不下；合成保留图、不含选块开销；不是端到端，也不是真实服务。</a:t>
+              <a:t>【每步构成】（32K dense，substrate/time_breakdown.json，v2 时期，KV 拼接已在 v3 去掉）forward 约 32 ms：MoE 专家矩阵乘 12.8 ms、GLOBAL 注意力 7.2 ms、其余矩阵乘 3.5 ms、LOCAL 0.8 ms、其他约 4 ms；另有采样约 4.6 ms。</a:t>
+            </a:r>
+          </a:p>
+          <a:p>
+            <a:r>
+              <a:t>【MoE】128 个专家、每 token 选 8 个；一步 256 个 canvas token × 8 = 2048 次分配，几乎所有专家都会被用到，所以每步要读全部专家权重（约 46 GB），12.8 ms 已接近 H100 的 HBM 带宽极限。</a:t>
+            </a:r>
+          </a:p>
+          <a:p>
+            <a:r>
+              <a:t>【GLOBAL 注意力】CUDA event 直接计时（kernel_bench/module_profile_*）：dense 每层 1.46 ms（32K）/ 2.95 ms（64K）；M3 R6 DP −ln2 摊到每步：32K 4.3 ms、64K 5.5 ms（dense 7.3 / 14.75 ms）。</a:t>
+            </a:r>
+          </a:p>
+          <a:p>
+            <a:r>
+              <a:t>【每步解码时间】（摊销，72 格平均）32K dense 37.3 ms、M3 34.7、B 33.5；64K dense 45.3、M3 37.2、B 36.1；AIME dense 30.7、M3 31.4。</a:t>
+            </a:r>
+          </a:p>
+          <a:p>
+            <a:r>
+              <a:t>【还能挖的】canvas 追加（encoder 与 decoder 共享权重，可复用最后的选块图）约 −1.4%（64K）；剩余观测/决策开销约 −1–2%。</a:t>
             </a:r>
           </a:p>
         </p:txBody>
@@ -1104,12 +1115,92 @@
           <a:lstStyle/>
           <a:p>
             <a:r>
+              <a:t>【脚本】scripts/v27_batch_step_bench.py（提交 02eead519），dlm2，E4 运行目录与部署；数据 results/m1_m2_m3_frontier_v27_20260929/batch_scaling/。</a:t>
+            </a:r>
+          </a:p>
+          <a:p>
+            <a:r>
+              <a:t>【口径】eager 的整次 decoder forward（含每次调用的 K/V 拼接，1.2/2.4/4.7 ms）一次性 CUDA graph 捕获后重放，CUDA event 取 15 次中位数；采样另测 2.5/4.8/9.4 ms。</a:t>
+            </a:r>
+          </a:p>
+          <a:p>
+            <a:r>
+              <a:t>【局限】只测了 64K 一个状态；batch 8 时复制的 64K 缓存放不下；合成保留图、不含选块开销；不是端到端，也不是真实服务。</a:t>
+            </a:r>
+          </a:p>
+        </p:txBody>
+      </p:sp>
+      <p:sp>
+        <p:nvSpPr>
+          <p:cNvPr id="4" name="Slide Number Placeholder 3"/>
+          <p:cNvSpPr>
+            <a:spLocks noGrp="1"/>
+          </p:cNvSpPr>
+          <p:nvPr>
+            <p:ph type="sldNum" idx="5" sz="quarter"/>
+          </p:nvPr>
+        </p:nvSpPr>
+        <p:spPr/>
+      </p:sp>
+    </p:spTree>
+  </p:cSld>
+  <p:clrMapOvr>
+    <a:masterClrMapping/>
+  </p:clrMapOvr>
+</p:notes>
+</file>
+
+<file path=ppt/notesSlides/notesSlide9.xml><?xml version="1.0" encoding="utf-8"?>
+<p:notes xmlns:a="http://schemas.openxmlformats.org/drawingml/2006/main" xmlns:p="http://schemas.openxmlformats.org/presentationml/2006/main" xmlns:r="http://schemas.openxmlformats.org/officeDocument/2006/relationships">
+  <p:cSld>
+    <p:spTree>
+      <p:nvGrpSpPr>
+        <p:cNvPr id="1" name=""/>
+        <p:cNvGrpSpPr/>
+        <p:nvPr/>
+      </p:nvGrpSpPr>
+      <p:grpSpPr>
+        <a:xfrm>
+          <a:off x="0" y="0"/>
+          <a:ext cx="0" cy="0"/>
+          <a:chOff x="0" y="0"/>
+          <a:chExt cx="0" cy="0"/>
+        </a:xfrm>
+      </p:grpSpPr>
+      <p:sp>
+        <p:nvSpPr>
+          <p:cNvPr id="2" name="Slide Image Placeholder 1"/>
+          <p:cNvSpPr>
+            <a:spLocks noGrp="1"/>
+          </p:cNvSpPr>
+          <p:nvPr>
+            <p:ph type="sldImg" idx="2"/>
+          </p:nvPr>
+        </p:nvSpPr>
+        <p:spPr/>
+      </p:sp>
+      <p:sp>
+        <p:nvSpPr>
+          <p:cNvPr id="3" name="Notes Placeholder 2"/>
+          <p:cNvSpPr>
+            <a:spLocks noGrp="1"/>
+          </p:cNvSpPr>
+          <p:nvPr>
+            <p:ph type="body" idx="3" sz="quarter"/>
+          </p:nvPr>
+        </p:nvSpPr>
+        <p:spPr/>
+        <p:txBody>
+          <a:bodyPr/>
+          <a:lstStyle/>
+          <a:p>
+            <a:r>
               <a:t>【组内证据（不是我们的，只引用）】JunyuLiao 的 value-direction 选块维度扫描（分支 ljy/value_aware，提交 8b29f942d、47c47d9d7）：RULER8K 稀疏度约 75% 时，V 投影 32 维 47.4%、全维 49.8%、只看注意力质量 21.3%、2 维 2.5%；50% 时都约 92%。他的选块用当前 QK，与我们的历史 QK 不同。</a:t>
             </a:r>
           </a:p>
           <a:p>
             <a:r>
-              <a:t>【可能的论文方向】(1) 评测方法学：自适应停止下 dLLM 加速需要大样本（dense 对照方差、本次 E4 推翻 3 seed 结论）；(2) 看 V 选块（取决于 E8）；(3) 与同学的 query 敏感度方向合作。批量服务方向在 64K、batch ≤ 4 时没有放大收益（见上一页）。</a:t>
+              <a:t>【可能的论文方向】(1) 评测方法学：自适应停止下 dLLM 加速需要大样本（dense 对照方差、本次 E4 推翻 3 seed 结论）；(2) 看 V 选块（E8 在 AIME 上为否，取决于 64K 的 E9）；(3) 与同学的 query 敏感度方向合作。批量服务方向在 64K、batch ≤ 4 时没有放大收益（见上一页）。</a:t>
             </a:r>
           </a:p>
         </p:txBody>
@@ -7185,6 +7276,927 @@
               <a:rPr sz="2400" b="1">
                 <a:latin typeface="Microsoft YaHei"/>
               </a:rPr>
+              <a:t>选块要不要看 V（E8，AIME，固定 70% 稀疏度）：没有证据表明看 V 更好</a:t>
+            </a:r>
+          </a:p>
+        </p:txBody>
+      </p:sp>
+      <p:sp>
+        <p:nvSpPr>
+          <p:cNvPr id="3" name="TextBox 2"/>
+          <p:cNvSpPr txBox="1"/>
+          <p:nvPr/>
+        </p:nvSpPr>
+        <p:spPr>
+          <a:xfrm>
+            <a:off x="457200" y="868680"/>
+            <a:ext cx="11247120" cy="548640"/>
+          </a:xfrm>
+          <a:prstGeom prst="rect">
+            <a:avLst/>
+          </a:prstGeom>
+          <a:noFill/>
+        </p:spPr>
+        <p:txBody>
+          <a:bodyPr wrap="square">
+            <a:spAutoFit/>
+          </a:bodyPr>
+          <a:lstStyle/>
+          <a:p>
+            <a:pPr>
+              <a:spcAft>
+                <a:spcPts val="400"/>
+              </a:spcAft>
+            </a:pPr>
+            <a:r>
+              <a:rPr sz="1200" b="0">
+                <a:solidFill>
+                  <a:srgbClr val="555555"/>
+                </a:solidFill>
+                <a:latin typeface="Microsoft YaHei"/>
+              </a:rPr>
+              <a:t>AIME26 30 题 × 6 个 seed = 180 格/方法 · 同一个 M3 R6 DP 选块器，固定保留 30% 的 prefix 块，只换风险里的 V 项 · SparseD（移植）70% 作参照 · dense = FA4 · 底座 v5 · 同格同机</a:t>
+            </a:r>
+          </a:p>
+        </p:txBody>
+      </p:sp>
+      <p:graphicFrame>
+        <p:nvGraphicFramePr>
+          <p:cNvPr id="4" name="Table 3"/>
+          <p:cNvGraphicFramePr>
+            <a:graphicFrameLocks noGrp="1"/>
+          </p:cNvGraphicFramePr>
+          <p:nvPr/>
+        </p:nvGraphicFramePr>
+        <p:xfrm>
+          <a:off x="365760" y="1463040"/>
+          <a:ext cx="11429999" cy="2926080"/>
+        </p:xfrm>
+        <a:graphic>
+          <a:graphicData uri="http://schemas.openxmlformats.org/drawingml/2006/table">
+            <a:tbl>
+              <a:tblPr firstRow="1" bandRow="1">
+                <a:tableStyleId>{5C22544A-7EE6-4342-B048-85BDC9FD1C3A}</a:tableStyleId>
+              </a:tblPr>
+              <a:tblGrid>
+                <a:gridCol w="3048000"/>
+                <a:gridCol w="1714500"/>
+                <a:gridCol w="2095500"/>
+                <a:gridCol w="2095500"/>
+                <a:gridCol w="1333499"/>
+                <a:gridCol w="1143000"/>
+              </a:tblGrid>
+              <a:tr h="365760">
+                <a:tc>
+                  <a:txBody>
+                    <a:bodyPr/>
+                    <a:lstStyle/>
+                    <a:p>
+                      <a:r>
+                        <a:rPr sz="1200" b="1">
+                          <a:latin typeface="Microsoft YaHei"/>
+                        </a:rPr>
+                        <a:t>V 项</a:t>
+                      </a:r>
+                    </a:p>
+                  </a:txBody>
+                  <a:tcPr/>
+                </a:tc>
+                <a:tc>
+                  <a:txBody>
+                    <a:bodyPr/>
+                    <a:lstStyle/>
+                    <a:p>
+                      <a:r>
+                        <a:rPr sz="1200" b="1">
+                          <a:latin typeface="Microsoft YaHei"/>
+                        </a:rPr>
+                        <a:t>答对（dense 99）</a:t>
+                      </a:r>
+                    </a:p>
+                  </a:txBody>
+                  <a:tcPr/>
+                </a:tc>
+                <a:tc>
+                  <a:txBody>
+                    <a:bodyPr/>
+                    <a:lstStyle/>
+                    <a:p>
+                      <a:r>
+                        <a:rPr sz="1200" b="1">
+                          <a:latin typeface="Microsoft YaHei"/>
+                        </a:rPr>
+                        <a:t>对 dense（p）</a:t>
+                      </a:r>
+                    </a:p>
+                  </a:txBody>
+                  <a:tcPr/>
+                </a:tc>
+                <a:tc>
+                  <a:txBody>
+                    <a:bodyPr/>
+                    <a:lstStyle/>
+                    <a:p>
+                      <a:r>
+                        <a:rPr sz="1200" b="1">
+                          <a:latin typeface="Microsoft YaHei"/>
+                        </a:rPr>
+                        <a:t>对投影 32 维（p）</a:t>
+                      </a:r>
+                    </a:p>
+                  </a:txBody>
+                  <a:tcPr/>
+                </a:tc>
+                <a:tc>
+                  <a:txBody>
+                    <a:bodyPr/>
+                    <a:lstStyle/>
+                    <a:p>
+                      <a:r>
+                        <a:rPr sz="1200" b="1">
+                          <a:latin typeface="Microsoft YaHei"/>
+                        </a:rPr>
+                        <a:t>端到端 W</a:t>
+                      </a:r>
+                    </a:p>
+                  </a:txBody>
+                  <a:tcPr/>
+                </a:tc>
+                <a:tc>
+                  <a:txBody>
+                    <a:bodyPr/>
+                    <a:lstStyle/>
+                    <a:p>
+                      <a:r>
+                        <a:rPr sz="1200" b="1">
+                          <a:latin typeface="Microsoft YaHei"/>
+                        </a:rPr>
+                        <a:t>步数 N</a:t>
+                      </a:r>
+                    </a:p>
+                  </a:txBody>
+                  <a:tcPr/>
+                </a:tc>
+              </a:tr>
+              <a:tr h="365760">
+                <a:tc>
+                  <a:txBody>
+                    <a:bodyPr/>
+                    <a:lstStyle/>
+                    <a:p>
+                      <a:r>
+                        <a:rPr sz="1200" b="0">
+                          <a:latin typeface="Microsoft YaHei"/>
+                        </a:rPr>
+                        <a:t>投影 V 32 维（当前）</a:t>
+                      </a:r>
+                    </a:p>
+                  </a:txBody>
+                  <a:tcPr/>
+                </a:tc>
+                <a:tc>
+                  <a:txBody>
+                    <a:bodyPr/>
+                    <a:lstStyle/>
+                    <a:p>
+                      <a:r>
+                        <a:rPr sz="1200" b="0">
+                          <a:latin typeface="Microsoft YaHei"/>
+                        </a:rPr>
+                        <a:t>87</a:t>
+                      </a:r>
+                    </a:p>
+                  </a:txBody>
+                  <a:tcPr/>
+                </a:tc>
+                <a:tc>
+                  <a:txBody>
+                    <a:bodyPr/>
+                    <a:lstStyle/>
+                    <a:p>
+                      <a:r>
+                        <a:rPr sz="1200" b="0">
+                          <a:latin typeface="Microsoft YaHei"/>
+                        </a:rPr>
+                        <a:t>+14/−26（0.08）</a:t>
+                      </a:r>
+                    </a:p>
+                  </a:txBody>
+                  <a:tcPr/>
+                </a:tc>
+                <a:tc>
+                  <a:txBody>
+                    <a:bodyPr/>
+                    <a:lstStyle/>
+                    <a:p>
+                      <a:r>
+                        <a:rPr sz="1200" b="0">
+                          <a:latin typeface="Microsoft YaHei"/>
+                        </a:rPr>
+                        <a:t>—</a:t>
+                      </a:r>
+                    </a:p>
+                  </a:txBody>
+                  <a:tcPr/>
+                </a:tc>
+                <a:tc>
+                  <a:txBody>
+                    <a:bodyPr/>
+                    <a:lstStyle/>
+                    <a:p>
+                      <a:r>
+                        <a:rPr sz="1200" b="0">
+                          <a:latin typeface="Microsoft YaHei"/>
+                        </a:rPr>
+                        <a:t>1.138</a:t>
+                      </a:r>
+                    </a:p>
+                  </a:txBody>
+                  <a:tcPr/>
+                </a:tc>
+                <a:tc>
+                  <a:txBody>
+                    <a:bodyPr/>
+                    <a:lstStyle/>
+                    <a:p>
+                      <a:r>
+                        <a:rPr sz="1200" b="0">
+                          <a:latin typeface="Microsoft YaHei"/>
+                        </a:rPr>
+                        <a:t>1.13</a:t>
+                      </a:r>
+                    </a:p>
+                  </a:txBody>
+                  <a:tcPr/>
+                </a:tc>
+              </a:tr>
+              <a:tr h="365760">
+                <a:tc>
+                  <a:txBody>
+                    <a:bodyPr/>
+                    <a:lstStyle/>
+                    <a:p>
+                      <a:r>
+                        <a:rPr sz="1200" b="0">
+                          <a:latin typeface="Microsoft YaHei"/>
+                        </a:rPr>
+                        <a:t>投影 V 16 维</a:t>
+                      </a:r>
+                    </a:p>
+                  </a:txBody>
+                  <a:tcPr/>
+                </a:tc>
+                <a:tc>
+                  <a:txBody>
+                    <a:bodyPr/>
+                    <a:lstStyle/>
+                    <a:p>
+                      <a:r>
+                        <a:rPr sz="1200" b="0">
+                          <a:latin typeface="Microsoft YaHei"/>
+                        </a:rPr>
+                        <a:t>86</a:t>
+                      </a:r>
+                    </a:p>
+                  </a:txBody>
+                  <a:tcPr/>
+                </a:tc>
+                <a:tc>
+                  <a:txBody>
+                    <a:bodyPr/>
+                    <a:lstStyle/>
+                    <a:p>
+                      <a:r>
+                        <a:rPr sz="1200" b="0">
+                          <a:latin typeface="Microsoft YaHei"/>
+                        </a:rPr>
+                        <a:t>+10/−23（0.035）</a:t>
+                      </a:r>
+                    </a:p>
+                  </a:txBody>
+                  <a:tcPr/>
+                </a:tc>
+                <a:tc>
+                  <a:txBody>
+                    <a:bodyPr/>
+                    <a:lstStyle/>
+                    <a:p>
+                      <a:r>
+                        <a:rPr sz="1200" b="0">
+                          <a:latin typeface="Microsoft YaHei"/>
+                        </a:rPr>
+                        <a:t>+15/−16（1.00）</a:t>
+                      </a:r>
+                    </a:p>
+                  </a:txBody>
+                  <a:tcPr/>
+                </a:tc>
+                <a:tc>
+                  <a:txBody>
+                    <a:bodyPr/>
+                    <a:lstStyle/>
+                    <a:p>
+                      <a:r>
+                        <a:rPr sz="1200" b="0">
+                          <a:latin typeface="Microsoft YaHei"/>
+                        </a:rPr>
+                        <a:t>1.119</a:t>
+                      </a:r>
+                    </a:p>
+                  </a:txBody>
+                  <a:tcPr/>
+                </a:tc>
+                <a:tc>
+                  <a:txBody>
+                    <a:bodyPr/>
+                    <a:lstStyle/>
+                    <a:p>
+                      <a:r>
+                        <a:rPr sz="1200" b="0">
+                          <a:latin typeface="Microsoft YaHei"/>
+                        </a:rPr>
+                        <a:t>1.11</a:t>
+                      </a:r>
+                    </a:p>
+                  </a:txBody>
+                  <a:tcPr/>
+                </a:tc>
+              </a:tr>
+              <a:tr h="365760">
+                <a:tc>
+                  <a:txBody>
+                    <a:bodyPr/>
+                    <a:lstStyle/>
+                    <a:p>
+                      <a:r>
+                        <a:rPr sz="1200" b="0">
+                          <a:latin typeface="Microsoft YaHei"/>
+                        </a:rPr>
+                        <a:t>投影 V 8 维</a:t>
+                      </a:r>
+                    </a:p>
+                  </a:txBody>
+                  <a:tcPr/>
+                </a:tc>
+                <a:tc>
+                  <a:txBody>
+                    <a:bodyPr/>
+                    <a:lstStyle/>
+                    <a:p>
+                      <a:r>
+                        <a:rPr sz="1200" b="0">
+                          <a:latin typeface="Microsoft YaHei"/>
+                        </a:rPr>
+                        <a:t>87</a:t>
+                      </a:r>
+                    </a:p>
+                  </a:txBody>
+                  <a:tcPr/>
+                </a:tc>
+                <a:tc>
+                  <a:txBody>
+                    <a:bodyPr/>
+                    <a:lstStyle/>
+                    <a:p>
+                      <a:r>
+                        <a:rPr sz="1200" b="0">
+                          <a:latin typeface="Microsoft YaHei"/>
+                        </a:rPr>
+                        <a:t>+8/−20（0.036）</a:t>
+                      </a:r>
+                    </a:p>
+                  </a:txBody>
+                  <a:tcPr/>
+                </a:tc>
+                <a:tc>
+                  <a:txBody>
+                    <a:bodyPr/>
+                    <a:lstStyle/>
+                    <a:p>
+                      <a:r>
+                        <a:rPr sz="1200" b="0">
+                          <a:latin typeface="Microsoft YaHei"/>
+                        </a:rPr>
+                        <a:t>+16/−16（1.00）</a:t>
+                      </a:r>
+                    </a:p>
+                  </a:txBody>
+                  <a:tcPr/>
+                </a:tc>
+                <a:tc>
+                  <a:txBody>
+                    <a:bodyPr/>
+                    <a:lstStyle/>
+                    <a:p>
+                      <a:r>
+                        <a:rPr sz="1200" b="0">
+                          <a:latin typeface="Microsoft YaHei"/>
+                        </a:rPr>
+                        <a:t>1.113</a:t>
+                      </a:r>
+                    </a:p>
+                  </a:txBody>
+                  <a:tcPr/>
+                </a:tc>
+                <a:tc>
+                  <a:txBody>
+                    <a:bodyPr/>
+                    <a:lstStyle/>
+                    <a:p>
+                      <a:r>
+                        <a:rPr sz="1200" b="0">
+                          <a:latin typeface="Microsoft YaHei"/>
+                        </a:rPr>
+                        <a:t>1.11</a:t>
+                      </a:r>
+                    </a:p>
+                  </a:txBody>
+                  <a:tcPr/>
+                </a:tc>
+              </a:tr>
+              <a:tr h="365760">
+                <a:tc>
+                  <a:txBody>
+                    <a:bodyPr/>
+                    <a:lstStyle/>
+                    <a:p>
+                      <a:r>
+                        <a:rPr sz="1200" b="0">
+                          <a:latin typeface="Microsoft YaHei"/>
+                        </a:rPr>
+                        <a:t>投影 V 4 维</a:t>
+                      </a:r>
+                    </a:p>
+                  </a:txBody>
+                  <a:tcPr/>
+                </a:tc>
+                <a:tc>
+                  <a:txBody>
+                    <a:bodyPr/>
+                    <a:lstStyle/>
+                    <a:p>
+                      <a:r>
+                        <a:rPr sz="1200" b="0">
+                          <a:latin typeface="Microsoft YaHei"/>
+                        </a:rPr>
+                        <a:t>94</a:t>
+                      </a:r>
+                    </a:p>
+                  </a:txBody>
+                  <a:tcPr/>
+                </a:tc>
+                <a:tc>
+                  <a:txBody>
+                    <a:bodyPr/>
+                    <a:lstStyle/>
+                    <a:p>
+                      <a:r>
+                        <a:rPr sz="1200" b="0">
+                          <a:latin typeface="Microsoft YaHei"/>
+                        </a:rPr>
+                        <a:t>+18/−23（0.53）</a:t>
+                      </a:r>
+                    </a:p>
+                  </a:txBody>
+                  <a:tcPr/>
+                </a:tc>
+                <a:tc>
+                  <a:txBody>
+                    <a:bodyPr/>
+                    <a:lstStyle/>
+                    <a:p>
+                      <a:r>
+                        <a:rPr sz="1200" b="0">
+                          <a:latin typeface="Microsoft YaHei"/>
+                        </a:rPr>
+                        <a:t>+20/−13（0.30）</a:t>
+                      </a:r>
+                    </a:p>
+                  </a:txBody>
+                  <a:tcPr/>
+                </a:tc>
+                <a:tc>
+                  <a:txBody>
+                    <a:bodyPr/>
+                    <a:lstStyle/>
+                    <a:p>
+                      <a:r>
+                        <a:rPr sz="1200" b="0">
+                          <a:latin typeface="Microsoft YaHei"/>
+                        </a:rPr>
+                        <a:t>1.131</a:t>
+                      </a:r>
+                    </a:p>
+                  </a:txBody>
+                  <a:tcPr/>
+                </a:tc>
+                <a:tc>
+                  <a:txBody>
+                    <a:bodyPr/>
+                    <a:lstStyle/>
+                    <a:p>
+                      <a:r>
+                        <a:rPr sz="1200" b="0">
+                          <a:latin typeface="Microsoft YaHei"/>
+                        </a:rPr>
+                        <a:t>1.13</a:t>
+                      </a:r>
+                    </a:p>
+                  </a:txBody>
+                  <a:tcPr/>
+                </a:tc>
+              </a:tr>
+              <a:tr h="365760">
+                <a:tc>
+                  <a:txBody>
+                    <a:bodyPr/>
+                    <a:lstStyle/>
+                    <a:p>
+                      <a:r>
+                        <a:rPr sz="1200" b="0">
+                          <a:latin typeface="Microsoft YaHei"/>
+                        </a:rPr>
+                        <a:t>M2 块均值 V</a:t>
+                      </a:r>
+                    </a:p>
+                  </a:txBody>
+                  <a:tcPr/>
+                </a:tc>
+                <a:tc>
+                  <a:txBody>
+                    <a:bodyPr/>
+                    <a:lstStyle/>
+                    <a:p>
+                      <a:r>
+                        <a:rPr sz="1200" b="0">
+                          <a:latin typeface="Microsoft YaHei"/>
+                        </a:rPr>
+                        <a:t>92</a:t>
+                      </a:r>
+                    </a:p>
+                  </a:txBody>
+                  <a:tcPr/>
+                </a:tc>
+                <a:tc>
+                  <a:txBody>
+                    <a:bodyPr/>
+                    <a:lstStyle/>
+                    <a:p>
+                      <a:r>
+                        <a:rPr sz="1200" b="0">
+                          <a:latin typeface="Microsoft YaHei"/>
+                        </a:rPr>
+                        <a:t>+13/−20（0.30）</a:t>
+                      </a:r>
+                    </a:p>
+                  </a:txBody>
+                  <a:tcPr/>
+                </a:tc>
+                <a:tc>
+                  <a:txBody>
+                    <a:bodyPr/>
+                    <a:lstStyle/>
+                    <a:p>
+                      <a:r>
+                        <a:rPr sz="1200" b="0">
+                          <a:latin typeface="Microsoft YaHei"/>
+                        </a:rPr>
+                        <a:t>+19/−14（0.49）</a:t>
+                      </a:r>
+                    </a:p>
+                  </a:txBody>
+                  <a:tcPr/>
+                </a:tc>
+                <a:tc>
+                  <a:txBody>
+                    <a:bodyPr/>
+                    <a:lstStyle/>
+                    <a:p>
+                      <a:r>
+                        <a:rPr sz="1200" b="0">
+                          <a:latin typeface="Microsoft YaHei"/>
+                        </a:rPr>
+                        <a:t>1.172</a:t>
+                      </a:r>
+                    </a:p>
+                  </a:txBody>
+                  <a:tcPr/>
+                </a:tc>
+                <a:tc>
+                  <a:txBody>
+                    <a:bodyPr/>
+                    <a:lstStyle/>
+                    <a:p>
+                      <a:r>
+                        <a:rPr sz="1200" b="0">
+                          <a:latin typeface="Microsoft YaHei"/>
+                        </a:rPr>
+                        <a:t>1.12</a:t>
+                      </a:r>
+                    </a:p>
+                  </a:txBody>
+                  <a:tcPr/>
+                </a:tc>
+              </a:tr>
+              <a:tr h="365760">
+                <a:tc>
+                  <a:txBody>
+                    <a:bodyPr/>
+                    <a:lstStyle/>
+                    <a:p>
+                      <a:r>
+                        <a:rPr sz="1200" b="0">
+                          <a:latin typeface="Microsoft YaHei"/>
+                        </a:rPr>
+                        <a:t>不看 V（只看注意力质量）</a:t>
+                      </a:r>
+                    </a:p>
+                  </a:txBody>
+                  <a:tcPr/>
+                </a:tc>
+                <a:tc>
+                  <a:txBody>
+                    <a:bodyPr/>
+                    <a:lstStyle/>
+                    <a:p>
+                      <a:r>
+                        <a:rPr sz="1200" b="0">
+                          <a:latin typeface="Microsoft YaHei"/>
+                        </a:rPr>
+                        <a:t>91</a:t>
+                      </a:r>
+                    </a:p>
+                  </a:txBody>
+                  <a:tcPr/>
+                </a:tc>
+                <a:tc>
+                  <a:txBody>
+                    <a:bodyPr/>
+                    <a:lstStyle/>
+                    <a:p>
+                      <a:r>
+                        <a:rPr sz="1200" b="0">
+                          <a:latin typeface="Microsoft YaHei"/>
+                        </a:rPr>
+                        <a:t>+15/−23（0.26）</a:t>
+                      </a:r>
+                    </a:p>
+                  </a:txBody>
+                  <a:tcPr/>
+                </a:tc>
+                <a:tc>
+                  <a:txBody>
+                    <a:bodyPr/>
+                    <a:lstStyle/>
+                    <a:p>
+                      <a:r>
+                        <a:rPr sz="1200" b="0">
+                          <a:latin typeface="Microsoft YaHei"/>
+                        </a:rPr>
+                        <a:t>+18/−14（0.60）</a:t>
+                      </a:r>
+                    </a:p>
+                  </a:txBody>
+                  <a:tcPr/>
+                </a:tc>
+                <a:tc>
+                  <a:txBody>
+                    <a:bodyPr/>
+                    <a:lstStyle/>
+                    <a:p>
+                      <a:r>
+                        <a:rPr sz="1200" b="0">
+                          <a:latin typeface="Microsoft YaHei"/>
+                        </a:rPr>
+                        <a:t>1.071</a:t>
+                      </a:r>
+                    </a:p>
+                  </a:txBody>
+                  <a:tcPr/>
+                </a:tc>
+                <a:tc>
+                  <a:txBody>
+                    <a:bodyPr/>
+                    <a:lstStyle/>
+                    <a:p>
+                      <a:r>
+                        <a:rPr sz="1200" b="0">
+                          <a:latin typeface="Microsoft YaHei"/>
+                        </a:rPr>
+                        <a:t>1.06</a:t>
+                      </a:r>
+                    </a:p>
+                  </a:txBody>
+                  <a:tcPr/>
+                </a:tc>
+              </a:tr>
+              <a:tr h="365760">
+                <a:tc>
+                  <a:txBody>
+                    <a:bodyPr/>
+                    <a:lstStyle/>
+                    <a:p>
+                      <a:r>
+                        <a:rPr sz="1200" b="0">
+                          <a:latin typeface="Microsoft YaHei"/>
+                        </a:rPr>
+                        <a:t>SparseD 70%（移植）</a:t>
+                      </a:r>
+                    </a:p>
+                  </a:txBody>
+                  <a:tcPr/>
+                </a:tc>
+                <a:tc>
+                  <a:txBody>
+                    <a:bodyPr/>
+                    <a:lstStyle/>
+                    <a:p>
+                      <a:r>
+                        <a:rPr sz="1200" b="0">
+                          <a:latin typeface="Microsoft YaHei"/>
+                        </a:rPr>
+                        <a:t>94</a:t>
+                      </a:r>
+                    </a:p>
+                  </a:txBody>
+                  <a:tcPr/>
+                </a:tc>
+                <a:tc>
+                  <a:txBody>
+                    <a:bodyPr/>
+                    <a:lstStyle/>
+                    <a:p>
+                      <a:r>
+                        <a:rPr sz="1200" b="0">
+                          <a:latin typeface="Microsoft YaHei"/>
+                        </a:rPr>
+                        <a:t>+13/−18（0.47）</a:t>
+                      </a:r>
+                    </a:p>
+                  </a:txBody>
+                  <a:tcPr/>
+                </a:tc>
+                <a:tc>
+                  <a:txBody>
+                    <a:bodyPr/>
+                    <a:lstStyle/>
+                    <a:p>
+                      <a:r>
+                        <a:rPr sz="1200" b="0">
+                          <a:latin typeface="Microsoft YaHei"/>
+                        </a:rPr>
+                        <a:t>+26/−19（0.37）</a:t>
+                      </a:r>
+                    </a:p>
+                  </a:txBody>
+                  <a:tcPr/>
+                </a:tc>
+                <a:tc>
+                  <a:txBody>
+                    <a:bodyPr/>
+                    <a:lstStyle/>
+                    <a:p>
+                      <a:r>
+                        <a:rPr sz="1200" b="0">
+                          <a:latin typeface="Microsoft YaHei"/>
+                        </a:rPr>
+                        <a:t>1.020</a:t>
+                      </a:r>
+                    </a:p>
+                  </a:txBody>
+                  <a:tcPr/>
+                </a:tc>
+                <a:tc>
+                  <a:txBody>
+                    <a:bodyPr/>
+                    <a:lstStyle/>
+                    <a:p>
+                      <a:r>
+                        <a:rPr sz="1200" b="0">
+                          <a:latin typeface="Microsoft YaHei"/>
+                        </a:rPr>
+                        <a:t>1.03</a:t>
+                      </a:r>
+                    </a:p>
+                  </a:txBody>
+                  <a:tcPr/>
+                </a:tc>
+              </a:tr>
+            </a:tbl>
+          </a:graphicData>
+        </a:graphic>
+      </p:graphicFrame>
+      <p:sp>
+        <p:nvSpPr>
+          <p:cNvPr id="5" name="TextBox 4"/>
+          <p:cNvSpPr txBox="1"/>
+          <p:nvPr/>
+        </p:nvSpPr>
+        <p:spPr>
+          <a:xfrm>
+            <a:off x="365760" y="4526280"/>
+            <a:ext cx="11430000" cy="2286000"/>
+          </a:xfrm>
+          <a:prstGeom prst="rect">
+            <a:avLst/>
+          </a:prstGeom>
+          <a:noFill/>
+        </p:spPr>
+        <p:txBody>
+          <a:bodyPr wrap="square">
+            <a:spAutoFit/>
+          </a:bodyPr>
+          <a:lstStyle/>
+          <a:p>
+            <a:pPr>
+              <a:spcAft>
+                <a:spcPts val="400"/>
+              </a:spcAft>
+            </a:pPr>
+            <a:r>
+              <a:rPr sz="1400" b="0">
+                <a:latin typeface="Microsoft YaHei"/>
+              </a:rPr>
+              <a:t>• 同稀疏度下没有任何 V 项显著优于“只看注意力质量”；投影 32/16/8 维反而最低，16/8 维显著低于 dense。</a:t>
+            </a:r>
+          </a:p>
+          <a:p>
+            <a:pPr>
+              <a:spcAft>
+                <a:spcPts val="400"/>
+              </a:spcAft>
+            </a:pPr>
+            <a:r>
+              <a:rPr sz="1400" b="0">
+                <a:latin typeface="Microsoft YaHei"/>
+              </a:rPr>
+              <a:t>• 降维没有单调趋势（4 维 94，8–32 维 86–87）：维度可调，但看不出“V 越准越好”。</a:t>
+            </a:r>
+          </a:p>
+          <a:p>
+            <a:pPr>
+              <a:spcAft>
+                <a:spcPts val="400"/>
+              </a:spcAft>
+            </a:pPr>
+            <a:r>
+              <a:rPr sz="1400" b="0">
+                <a:latin typeface="Microsoft YaHei"/>
+              </a:rPr>
+              <a:t>• 结论：AIME 上“看 V 选块”的新颖性主张不成立；64K 同类对照（E9，M3 + carry0，固定 88% 稀疏度）今晚出结果。</a:t>
+            </a:r>
+          </a:p>
+        </p:txBody>
+      </p:sp>
+    </p:spTree>
+  </p:cSld>
+  <p:clrMapOvr>
+    <a:masterClrMapping/>
+  </p:clrMapOvr>
+</p:sld>
+</file>
+
+<file path=ppt/slides/slide7.xml><?xml version="1.0" encoding="utf-8"?>
+<p:sld xmlns:a="http://schemas.openxmlformats.org/drawingml/2006/main" xmlns:p="http://schemas.openxmlformats.org/presentationml/2006/main" xmlns:r="http://schemas.openxmlformats.org/officeDocument/2006/relationships">
+  <p:cSld>
+    <p:spTree>
+      <p:nvGrpSpPr>
+        <p:cNvPr id="1" name=""/>
+        <p:cNvGrpSpPr/>
+        <p:nvPr/>
+      </p:nvGrpSpPr>
+      <p:grpSpPr/>
+      <p:sp>
+        <p:nvSpPr>
+          <p:cNvPr id="2" name="TextBox 1"/>
+          <p:cNvSpPr txBox="1"/>
+          <p:nvPr/>
+        </p:nvSpPr>
+        <p:spPr>
+          <a:xfrm>
+            <a:off x="457200" y="274320"/>
+            <a:ext cx="11247120" cy="640080"/>
+          </a:xfrm>
+          <a:prstGeom prst="rect">
+            <a:avLst/>
+          </a:prstGeom>
+          <a:noFill/>
+        </p:spPr>
+        <p:txBody>
+          <a:bodyPr wrap="square">
+            <a:spAutoFit/>
+          </a:bodyPr>
+          <a:lstStyle/>
+          <a:p>
+            <a:pPr>
+              <a:spcAft>
+                <a:spcPts val="400"/>
+              </a:spcAft>
+            </a:pPr>
+            <a:r>
+              <a:rPr sz="2400" b="1">
+                <a:latin typeface="Microsoft YaHei"/>
+              </a:rPr>
               <a:t>时间都花在哪：为什么单请求下注意力稀疏的收益有上限</a:t>
             </a:r>
           </a:p>
@@ -7686,7 +8698,7 @@
 </p:sld>
 </file>
 
-<file path=ppt/slides/slide7.xml><?xml version="1.0" encoding="utf-8"?>
+<file path=ppt/slides/slide8.xml><?xml version="1.0" encoding="utf-8"?>
 <p:sld xmlns:a="http://schemas.openxmlformats.org/drawingml/2006/main" xmlns:p="http://schemas.openxmlformats.org/presentationml/2006/main" xmlns:r="http://schemas.openxmlformats.org/officeDocument/2006/relationships">
   <p:cSld>
     <p:spTree>
@@ -8290,7 +9302,7 @@
 </p:sld>
 </file>
 
-<file path=ppt/slides/slide8.xml><?xml version="1.0" encoding="utf-8"?>
+<file path=ppt/slides/slide9.xml><?xml version="1.0" encoding="utf-8"?>
 <p:sld xmlns:a="http://schemas.openxmlformats.org/drawingml/2006/main" xmlns:p="http://schemas.openxmlformats.org/presentationml/2006/main" xmlns:r="http://schemas.openxmlformats.org/officeDocument/2006/relationships">
   <p:cSld>
     <p:spTree>
@@ -8806,7 +9818,7 @@
               <a:rPr sz="1400" b="0">
                 <a:latin typeface="Microsoft YaHei"/>
               </a:rPr>
-              <a:t>• "每块选一次、复用"已被 SparseD / MAGE / HERALD 覆盖；"看 V 的选块更好"有待 E8 检验。</a:t>
+              <a:t>• "每块选一次、复用"已被 SparseD / MAGE / HERALD 覆盖；"看 V 的选块更好"没有数据支持（E8：AIME 70% 稀疏度下无 V 项优于只看注意力质量）；64K 对照 E9 待出。</a:t>
             </a:r>
           </a:p>
           <a:p>

</xml_diff>

<commit_message>
E6b and pooled 96K (11 items x 6 seeds): M3+c0 W 0.822 [0.703, 0.944], S 0.727, acc 30 vs 25; docs, slide source and deck updated
Co-Authored-By: Claude Opus 5.5 <noreply@anthropic.com>
</commit_message>
<xml_diff>
--- a/results/m1_m2_m3_frontier_v27_20260929/ppt_sample/dlm_sparse_attention_20261001.pptx
+++ b/results/m1_m2_m3_frontier_v27_20260929/ppt_sample/dlm_sparse_attention_20261001.pptx
@@ -770,22 +770,22 @@
           <a:lstStyle/>
           <a:p>
             <a:r>
-              <a:t>【协议】v27_lb96k_confirm_e6_8ab3aa35d1874ca1（specs/v27_lb96k_confirm_e6.json）；252/252 次运行成功，计时中无新图，每格同机（dllm、mpk）；carry0 收据：每请求 5 次 dense 引导。</a:t>
-            </a:r>
-          </a:p>
-          <a:p>
-            <a:r>
-              <a:t>【数据】96K 档共 12 道题，另 6 道 prompt ≥ 98K token，在单卡 prefill 时所有方法（包括 dense）都 OOM；128K 档同样 OOM（76.7 GiB 已分配时再申请 1.38 GiB 失败）。</a:t>
-            </a:r>
-          </a:p>
-          <a:p>
-            <a:r>
-              <a:t>【单题差异】M3 + carry0 / dense 的单格比值在 0.28–1.30 之间。</a:t>
-            </a:r>
-          </a:p>
-          <a:p>
-            <a:r>
-              <a:t>【数据路径】results/m1_m2_m3_frontier_v27_20260929/lb96k_confirm_panel_e6/summary.md</a:t>
+              <a:t>【协议】E6 v27_lb96k_confirm_e6_8ab3aa35d1874ca1（252/252 成功，dllm、mpk）；E6b v27_lb96k_extend_e6b_d1b1c0c74a1dc69d（210/210 成功，dllm、mpk、dlm2），计时中无新图；carry0 收据：每请求 5 次 dense 引导。E6b 部署比 E6 晚一个代码提交（只加了默认关闭的 V 项选项）。</a:t>
+            </a:r>
+          </a:p>
+          <a:p>
+            <a:r>
+              <a:t>【选题】LongBench-v2 共 32 道题落在 84–104K 档，14 道单卡放得下；冻结题池按 sha256 取前 24 道，其中 11 道放得下（全部用上），另 3 道在题池外。≥ 98,282 token 的题所有方法（包括 dense）prefill 都 OOM。</a:t>
+            </a:r>
+          </a:p>
+          <a:p>
+            <a:r>
+              <a:t>【分开看】E6（6 题）M3 + carry0 W 0.744、N 0.81；E6b（5 题）W 0.927 [0.782, 1.052]、N 1.19；每步比值一致（0.762 / 0.745）。</a:t>
+            </a:r>
+          </a:p>
+          <a:p>
+            <a:r>
+              <a:t>【数据路径】results/m1_m2_m3_frontier_v27_20260929/lb96k_pooled_e6_e6b/summary.md</a:t>
             </a:r>
           </a:p>
         </p:txBody>
@@ -5986,7 +5986,7 @@
               <a:rPr sz="2400" b="1">
                 <a:latin typeface="Microsoft YaHei"/>
               </a:rPr>
-              <a:t>96K：每步省 24%，端到端快 18–26%（6 道题，置信区间宽）</a:t>
+              <a:t>96K（11 道题 × 6 个 seed）：端到端快 18%，纯生成快 27%，每步省 25%，精度不降</a:t>
             </a:r>
           </a:p>
         </p:txBody>
@@ -6025,7 +6025,7 @@
                 </a:solidFill>
                 <a:latin typeface="Microsoft YaHei"/>
               </a:rPr>
-              <a:t>LongBench-v2 96K 档中单卡放得下的 6 道题（prompt ≤ 约 95K token）× 6 个 seed（404–909）= 36 格/方法 · dense = FA4 · 底座 v5 · 同格同机</a:t>
+              <a:t>LongBench-v2 96K 档题池中单卡放得下的全部 11 道题（prompt ≤ 95,074 token）× 6 个 seed（404–909）= 66 格/方法 · E6 + E6b 合并 · dense = FA4 · 底座 v5 · 同格同机</a:t>
             </a:r>
           </a:p>
         </p:txBody>
@@ -6040,7 +6040,7 @@
         </p:nvGraphicFramePr>
         <p:xfrm>
           <a:off x="365760" y="1463040"/>
-          <a:ext cx="11429999" cy="1828800"/>
+          <a:ext cx="11429996" cy="1828800"/>
         </p:xfrm>
         <a:graphic>
           <a:graphicData uri="http://schemas.openxmlformats.org/drawingml/2006/table">
@@ -6049,12 +6049,12 @@
                 <a:tableStyleId>{5C22544A-7EE6-4342-B048-85BDC9FD1C3A}</a:tableStyleId>
               </a:tblPr>
               <a:tblGrid>
-                <a:gridCol w="2857500"/>
-                <a:gridCol w="2190749"/>
-                <a:gridCol w="1238250"/>
-                <a:gridCol w="2286000"/>
-                <a:gridCol w="1143000"/>
-                <a:gridCol w="1714500"/>
+                <a:gridCol w="2721428"/>
+                <a:gridCol w="2086428"/>
+                <a:gridCol w="2086428"/>
+                <a:gridCol w="2177142"/>
+                <a:gridCol w="907142"/>
+                <a:gridCol w="1451428"/>
               </a:tblGrid>
               <a:tr h="365760">
                 <a:tc>
@@ -6096,7 +6096,7 @@
                         <a:rPr sz="1200" b="1">
                           <a:latin typeface="Microsoft YaHei"/>
                         </a:rPr>
-                        <a:t>纯生成 S</a:t>
+                        <a:t>纯生成 S [95% CI]</a:t>
                       </a:r>
                     </a:p>
                   </a:txBody>
@@ -6141,7 +6141,7 @@
                         <a:rPr sz="1200" b="1">
                           <a:latin typeface="Microsoft YaHei"/>
                         </a:rPr>
-                        <a:t>答对（dense 12）</a:t>
+                        <a:t>答对（dense 25）</a:t>
                       </a:r>
                     </a:p>
                   </a:txBody>
@@ -6173,7 +6173,7 @@
                         <a:rPr sz="1200" b="1">
                           <a:latin typeface="Microsoft YaHei"/>
                         </a:rPr>
-                        <a:t>0.744 [0.597, 0.903]</a:t>
+                        <a:t>0.822 [0.703, 0.944]</a:t>
                       </a:r>
                     </a:p>
                   </a:txBody>
@@ -6188,7 +6188,7 @@
                         <a:rPr sz="1200" b="1">
                           <a:latin typeface="Microsoft YaHei"/>
                         </a:rPr>
-                        <a:t>0.619</a:t>
+                        <a:t>0.727 [0.589, 0.887]</a:t>
                       </a:r>
                     </a:p>
                   </a:txBody>
@@ -6203,7 +6203,7 @@
                         <a:rPr sz="1200" b="1">
                           <a:latin typeface="Microsoft YaHei"/>
                         </a:rPr>
-                        <a:t>0.762 [0.747, 0.776]</a:t>
+                        <a:t>0.754 [0.738, 0.768]</a:t>
                       </a:r>
                     </a:p>
                   </a:txBody>
@@ -6218,7 +6218,7 @@
                         <a:rPr sz="1200" b="1">
                           <a:latin typeface="Microsoft YaHei"/>
                         </a:rPr>
-                        <a:t>0.81</a:t>
+                        <a:t>0.96</a:t>
                       </a:r>
                     </a:p>
                   </a:txBody>
@@ -6233,7 +6233,7 @@
                         <a:rPr sz="1200" b="1">
                           <a:latin typeface="Microsoft YaHei"/>
                         </a:rPr>
-                        <a:t>16</a:t>
+                        <a:t>30</a:t>
                       </a:r>
                     </a:p>
                   </a:txBody>
@@ -6265,67 +6265,67 @@
                         <a:rPr sz="1200" b="0">
                           <a:latin typeface="Microsoft YaHei"/>
                         </a:rPr>
-                        <a:t>0.819 [0.690, 0.968]</a:t>
-                      </a:r>
-                    </a:p>
-                  </a:txBody>
-                  <a:tcPr/>
-                </a:tc>
-                <a:tc>
-                  <a:txBody>
-                    <a:bodyPr/>
-                    <a:lstStyle/>
-                    <a:p>
-                      <a:r>
-                        <a:rPr sz="1200" b="0">
-                          <a:latin typeface="Microsoft YaHei"/>
-                        </a:rPr>
-                        <a:t>0.720</a:t>
-                      </a:r>
-                    </a:p>
-                  </a:txBody>
-                  <a:tcPr/>
-                </a:tc>
-                <a:tc>
-                  <a:txBody>
-                    <a:bodyPr/>
-                    <a:lstStyle/>
-                    <a:p>
-                      <a:r>
-                        <a:rPr sz="1200" b="0">
-                          <a:latin typeface="Microsoft YaHei"/>
-                        </a:rPr>
-                        <a:t>0.762 [0.731, 0.785]</a:t>
-                      </a:r>
-                    </a:p>
-                  </a:txBody>
-                  <a:tcPr/>
-                </a:tc>
-                <a:tc>
-                  <a:txBody>
-                    <a:bodyPr/>
-                    <a:lstStyle/>
-                    <a:p>
-                      <a:r>
-                        <a:rPr sz="1200" b="0">
-                          <a:latin typeface="Microsoft YaHei"/>
-                        </a:rPr>
-                        <a:t>0.95</a:t>
-                      </a:r>
-                    </a:p>
-                  </a:txBody>
-                  <a:tcPr/>
-                </a:tc>
-                <a:tc>
-                  <a:txBody>
-                    <a:bodyPr/>
-                    <a:lstStyle/>
-                    <a:p>
-                      <a:r>
-                        <a:rPr sz="1200" b="0">
-                          <a:latin typeface="Microsoft YaHei"/>
-                        </a:rPr>
-                        <a:t>14</a:t>
+                        <a:t>0.858 [0.761, 0.956]</a:t>
+                      </a:r>
+                    </a:p>
+                  </a:txBody>
+                  <a:tcPr/>
+                </a:tc>
+                <a:tc>
+                  <a:txBody>
+                    <a:bodyPr/>
+                    <a:lstStyle/>
+                    <a:p>
+                      <a:r>
+                        <a:rPr sz="1200" b="0">
+                          <a:latin typeface="Microsoft YaHei"/>
+                        </a:rPr>
+                        <a:t>0.783 [0.664, 0.918]</a:t>
+                      </a:r>
+                    </a:p>
+                  </a:txBody>
+                  <a:tcPr/>
+                </a:tc>
+                <a:tc>
+                  <a:txBody>
+                    <a:bodyPr/>
+                    <a:lstStyle/>
+                    <a:p>
+                      <a:r>
+                        <a:rPr sz="1200" b="0">
+                          <a:latin typeface="Microsoft YaHei"/>
+                        </a:rPr>
+                        <a:t>0.761 [0.740, 0.781]</a:t>
+                      </a:r>
+                    </a:p>
+                  </a:txBody>
+                  <a:tcPr/>
+                </a:tc>
+                <a:tc>
+                  <a:txBody>
+                    <a:bodyPr/>
+                    <a:lstStyle/>
+                    <a:p>
+                      <a:r>
+                        <a:rPr sz="1200" b="0">
+                          <a:latin typeface="Microsoft YaHei"/>
+                        </a:rPr>
+                        <a:t>1.03</a:t>
+                      </a:r>
+                    </a:p>
+                  </a:txBody>
+                  <a:tcPr/>
+                </a:tc>
+                <a:tc>
+                  <a:txBody>
+                    <a:bodyPr/>
+                    <a:lstStyle/>
+                    <a:p>
+                      <a:r>
+                        <a:rPr sz="1200" b="0">
+                          <a:latin typeface="Microsoft YaHei"/>
+                        </a:rPr>
+                        <a:t>31</a:t>
                       </a:r>
                     </a:p>
                   </a:txBody>
@@ -6357,67 +6357,67 @@
                         <a:rPr sz="1200" b="0">
                           <a:latin typeface="Microsoft YaHei"/>
                         </a:rPr>
-                        <a:t>0.786 [0.641, 0.946]</a:t>
-                      </a:r>
-                    </a:p>
-                  </a:txBody>
-                  <a:tcPr/>
-                </a:tc>
-                <a:tc>
-                  <a:txBody>
-                    <a:bodyPr/>
-                    <a:lstStyle/>
-                    <a:p>
-                      <a:r>
-                        <a:rPr sz="1200" b="0">
-                          <a:latin typeface="Microsoft YaHei"/>
-                        </a:rPr>
-                        <a:t>0.668</a:t>
-                      </a:r>
-                    </a:p>
-                  </a:txBody>
-                  <a:tcPr/>
-                </a:tc>
-                <a:tc>
-                  <a:txBody>
-                    <a:bodyPr/>
-                    <a:lstStyle/>
-                    <a:p>
-                      <a:r>
-                        <a:rPr sz="1200" b="0">
-                          <a:latin typeface="Microsoft YaHei"/>
-                        </a:rPr>
-                        <a:t>0.743 [0.722, 0.760]</a:t>
-                      </a:r>
-                    </a:p>
-                  </a:txBody>
-                  <a:tcPr/>
-                </a:tc>
-                <a:tc>
-                  <a:txBody>
-                    <a:bodyPr/>
-                    <a:lstStyle/>
-                    <a:p>
-                      <a:r>
-                        <a:rPr sz="1200" b="0">
-                          <a:latin typeface="Microsoft YaHei"/>
-                        </a:rPr>
-                        <a:t>0.90</a:t>
-                      </a:r>
-                    </a:p>
-                  </a:txBody>
-                  <a:tcPr/>
-                </a:tc>
-                <a:tc>
-                  <a:txBody>
-                    <a:bodyPr/>
-                    <a:lstStyle/>
-                    <a:p>
-                      <a:r>
-                        <a:rPr sz="1200" b="0">
-                          <a:latin typeface="Microsoft YaHei"/>
-                        </a:rPr>
-                        <a:t>16</a:t>
+                        <a:t>0.865 [0.752, 0.969]</a:t>
+                      </a:r>
+                    </a:p>
+                  </a:txBody>
+                  <a:tcPr/>
+                </a:tc>
+                <a:tc>
+                  <a:txBody>
+                    <a:bodyPr/>
+                    <a:lstStyle/>
+                    <a:p>
+                      <a:r>
+                        <a:rPr sz="1200" b="0">
+                          <a:latin typeface="Microsoft YaHei"/>
+                        </a:rPr>
+                        <a:t>0.789 [0.655, 0.928]</a:t>
+                      </a:r>
+                    </a:p>
+                  </a:txBody>
+                  <a:tcPr/>
+                </a:tc>
+                <a:tc>
+                  <a:txBody>
+                    <a:bodyPr/>
+                    <a:lstStyle/>
+                    <a:p>
+                      <a:r>
+                        <a:rPr sz="1200" b="0">
+                          <a:latin typeface="Microsoft YaHei"/>
+                        </a:rPr>
+                        <a:t>0.738 [0.725, 0.751]</a:t>
+                      </a:r>
+                    </a:p>
+                  </a:txBody>
+                  <a:tcPr/>
+                </a:tc>
+                <a:tc>
+                  <a:txBody>
+                    <a:bodyPr/>
+                    <a:lstStyle/>
+                    <a:p>
+                      <a:r>
+                        <a:rPr sz="1200" b="0">
+                          <a:latin typeface="Microsoft YaHei"/>
+                        </a:rPr>
+                        <a:t>1.07</a:t>
+                      </a:r>
+                    </a:p>
+                  </a:txBody>
+                  <a:tcPr/>
+                </a:tc>
+                <a:tc>
+                  <a:txBody>
+                    <a:bodyPr/>
+                    <a:lstStyle/>
+                    <a:p>
+                      <a:r>
+                        <a:rPr sz="1200" b="0">
+                          <a:latin typeface="Microsoft YaHei"/>
+                        </a:rPr>
+                        <a:t>31</a:t>
                       </a:r>
                     </a:p>
                   </a:txBody>
@@ -6449,7 +6449,37 @@
                         <a:rPr sz="1200" b="0">
                           <a:latin typeface="Microsoft YaHei"/>
                         </a:rPr>
-                        <a:t>1.158 / 1.385 / 1.045</a:t>
+                        <a:t>1.257 / 1.448 / 1.121</a:t>
+                      </a:r>
+                    </a:p>
+                  </a:txBody>
+                  <a:tcPr/>
+                </a:tc>
+                <a:tc>
+                  <a:txBody>
+                    <a:bodyPr/>
+                    <a:lstStyle/>
+                    <a:p>
+                      <a:r>
+                        <a:rPr sz="1200" b="0">
+                          <a:latin typeface="Microsoft YaHei"/>
+                        </a:rPr>
+                        <a:t>1.48 / 1.80 / 1.22</a:t>
+                      </a:r>
+                    </a:p>
+                  </a:txBody>
+                  <a:tcPr/>
+                </a:tc>
+                <a:tc>
+                  <a:txBody>
+                    <a:bodyPr/>
+                    <a:lstStyle/>
+                    <a:p>
+                      <a:r>
+                        <a:rPr sz="1200" b="0">
+                          <a:latin typeface="Microsoft YaHei"/>
+                        </a:rPr>
+                        <a:t>1.59 / 1.83 / 1.22</a:t>
                       </a:r>
                     </a:p>
                   </a:txBody>
@@ -6479,37 +6509,7 @@
                         <a:rPr sz="1200" b="0">
                           <a:latin typeface="Microsoft YaHei"/>
                         </a:rPr>
-                        <a:t>1.62 / 1.83 / 1.25</a:t>
-                      </a:r>
-                    </a:p>
-                  </a:txBody>
-                  <a:tcPr/>
-                </a:tc>
-                <a:tc>
-                  <a:txBody>
-                    <a:bodyPr/>
-                    <a:lstStyle/>
-                    <a:p>
-                      <a:r>
-                        <a:rPr sz="1200" b="0">
-                          <a:latin typeface="Microsoft YaHei"/>
-                        </a:rPr>
-                        <a:t>—</a:t>
-                      </a:r>
-                    </a:p>
-                  </a:txBody>
-                  <a:tcPr/>
-                </a:tc>
-                <a:tc>
-                  <a:txBody>
-                    <a:bodyPr/>
-                    <a:lstStyle/>
-                    <a:p>
-                      <a:r>
-                        <a:rPr sz="1200" b="0">
-                          <a:latin typeface="Microsoft YaHei"/>
-                        </a:rPr>
-                        <a:t>14 / 17 / 15</a:t>
+                        <a:t>32 / 32 / 33</a:t>
                       </a:r>
                     </a:p>
                   </a:txBody>
@@ -6551,7 +6551,7 @@
               <a:rPr sz="1400" b="0">
                 <a:latin typeface="Microsoft YaHei"/>
               </a:rPr>
-              <a:t>• 上下文越长每步省得越多：32K 约 8%、64K 约 18–20%、96K 约 24–26%（每步的置信区间都很窄）。</a:t>
+              <a:t>• 上下文越长每步省得越多：32K 约 8%、64K 约 18–20%、96K 约 25%（每步的置信区间都很窄）。</a:t>
             </a:r>
           </a:p>
           <a:p>
@@ -6564,7 +6564,7 @@
               <a:rPr sz="1400" b="0">
                 <a:latin typeface="Microsoft YaHei"/>
               </a:rPr>
-              <a:t>• 96K 端到端里有一部分来自步数少（N 0.81），6 道题时噪声很大；若步数不变，端到端预期约 0.85。精度不降。</a:t>
+              <a:t>• 合并 11 题后步数中性（N 0.96），端到端 −18%、纯生成 −27%，置信区间不含 1；精度不降。</a:t>
             </a:r>
           </a:p>
           <a:p>
@@ -6577,7 +6577,7 @@
               <a:rPr sz="1400" b="0">
                 <a:latin typeface="Microsoft YaHei"/>
               </a:rPr>
-              <a:t>• 128K 在单卡上 prefill 就 OOM（dense 也一样），需要分块 prefill。</a:t>
+              <a:t>• 只看 6 道题时步数会偏到 0.81 或 1.19：96K 的请求级结论只用合并面板。128K 需要分块 prefill。</a:t>
             </a:r>
           </a:p>
         </p:txBody>

</xml_diff>

<commit_message>
E9 results (64K, M3+c0, fixed 88%: attention-mass ranking as accurate and fast as any V term; V term dropped as a claim); docs, slide source and deck updated
Co-Authored-By: Claude Opus 5.5 <noreply@anthropic.com>
</commit_message>
<xml_diff>
--- a/results/m1_m2_m3_frontier_v27_20260929/ppt_sample/dlm_sparse_attention_20261001.pptx
+++ b/results/m1_m2_m3_frontier_v27_20260929/ppt_sample/dlm_sparse_attention_20261001.pptx
@@ -14,6 +14,7 @@
     <p:sldId id="262" r:id="rId14"/>
     <p:sldId id="263" r:id="rId15"/>
     <p:sldId id="264" r:id="rId16"/>
+    <p:sldId id="265" r:id="rId17"/>
   </p:sldIdLst>
   <p:sldSz cx="12191695" cy="6858000" type="screen4x3"/>
   <p:notesSz cx="6858000" cy="9144000"/>
@@ -535,6 +536,81 @@
 </p:notes>
 </file>
 
+<file path=ppt/notesSlides/notesSlide10.xml><?xml version="1.0" encoding="utf-8"?>
+<p:notes xmlns:a="http://schemas.openxmlformats.org/drawingml/2006/main" xmlns:p="http://schemas.openxmlformats.org/presentationml/2006/main" xmlns:r="http://schemas.openxmlformats.org/officeDocument/2006/relationships">
+  <p:cSld>
+    <p:spTree>
+      <p:nvGrpSpPr>
+        <p:cNvPr id="1" name=""/>
+        <p:cNvGrpSpPr/>
+        <p:nvPr/>
+      </p:nvGrpSpPr>
+      <p:grpSpPr>
+        <a:xfrm>
+          <a:off x="0" y="0"/>
+          <a:ext cx="0" cy="0"/>
+          <a:chOff x="0" y="0"/>
+          <a:chExt cx="0" cy="0"/>
+        </a:xfrm>
+      </p:grpSpPr>
+      <p:sp>
+        <p:nvSpPr>
+          <p:cNvPr id="2" name="Slide Image Placeholder 1"/>
+          <p:cNvSpPr>
+            <a:spLocks noGrp="1"/>
+          </p:cNvSpPr>
+          <p:nvPr>
+            <p:ph type="sldImg" idx="2"/>
+          </p:nvPr>
+        </p:nvSpPr>
+        <p:spPr/>
+      </p:sp>
+      <p:sp>
+        <p:nvSpPr>
+          <p:cNvPr id="3" name="Notes Placeholder 2"/>
+          <p:cNvSpPr>
+            <a:spLocks noGrp="1"/>
+          </p:cNvSpPr>
+          <p:nvPr>
+            <p:ph type="body" idx="3" sz="quarter"/>
+          </p:nvPr>
+        </p:nvSpPr>
+        <p:spPr/>
+        <p:txBody>
+          <a:bodyPr/>
+          <a:lstStyle/>
+          <a:p>
+            <a:r>
+              <a:t>【组内证据（不是我们的，只引用）】JunyuLiao 的 value-direction 选块维度扫描（分支 ljy/value_aware，提交 8b29f942d、47c47d9d7）：RULER8K 稀疏度约 75% 时，V 投影 32 维 47.4%、全维 49.8%、只看注意力质量 21.3%、2 维 2.5%；50% 时都约 92%。他的选块用当前 QK，与我们的历史 QK 不同。</a:t>
+            </a:r>
+          </a:p>
+          <a:p>
+            <a:r>
+              <a:t>【可能的论文方向】(1) 评测方法学：自适应停止下 dLLM 加速需要大样本（dense 对照方差、本次 E4 推翻 3 seed 结论）；(2) 看 V 选块已被 E8/E9 否定，不再作为方向；(3) 与同学的 query 敏感度方向合作。批量服务方向在 64K、batch ≤ 4 时没有放大收益（见上一页）。</a:t>
+            </a:r>
+          </a:p>
+        </p:txBody>
+      </p:sp>
+      <p:sp>
+        <p:nvSpPr>
+          <p:cNvPr id="4" name="Slide Number Placeholder 3"/>
+          <p:cNvSpPr>
+            <a:spLocks noGrp="1"/>
+          </p:cNvSpPr>
+          <p:nvPr>
+            <p:ph type="sldNum" idx="5" sz="quarter"/>
+          </p:nvPr>
+        </p:nvSpPr>
+        <p:spPr/>
+      </p:sp>
+    </p:spTree>
+  </p:cSld>
+  <p:clrMapOvr>
+    <a:masterClrMapping/>
+  </p:clrMapOvr>
+</p:notes>
+</file>
+
 <file path=ppt/notesSlides/notesSlide2.xml><?xml version="1.0" encoding="utf-8"?>
 <p:notes xmlns:a="http://schemas.openxmlformats.org/drawingml/2006/main" xmlns:p="http://schemas.openxmlformats.org/presentationml/2006/main" xmlns:r="http://schemas.openxmlformats.org/officeDocument/2006/relationships">
   <p:cSld>
@@ -1025,27 +1101,22 @@
           <a:lstStyle/>
           <a:p>
             <a:r>
-              <a:t>【每步构成】（32K dense，substrate/time_breakdown.json，v2 时期，KV 拼接已在 v3 去掉）forward 约 32 ms：MoE 专家矩阵乘 12.8 ms、GLOBAL 注意力 7.2 ms、其余矩阵乘 3.5 ms、LOCAL 0.8 ms、其他约 4 ms；另有采样约 4.6 ms。</a:t>
-            </a:r>
-          </a:p>
-          <a:p>
-            <a:r>
-              <a:t>【MoE】128 个专家、每 token 选 8 个；一步 256 个 canvas token × 8 = 2048 次分配，几乎所有专家都会被用到，所以每步要读全部专家权重（约 46 GB），12.8 ms 已接近 H100 的 HBM 带宽极限。</a:t>
-            </a:r>
-          </a:p>
-          <a:p>
-            <a:r>
-              <a:t>【GLOBAL 注意力】CUDA event 直接计时（kernel_bench/module_profile_*）：dense 每层 1.46 ms（32K）/ 2.95 ms（64K）；M3 R6 DP −ln2 摊到每步：32K 4.3 ms、64K 5.5 ms（dense 7.3 / 14.75 ms）。</a:t>
-            </a:r>
-          </a:p>
-          <a:p>
-            <a:r>
-              <a:t>【每步解码时间】（摊销，72 格平均）32K dense 37.3 ms、M3 34.7、B 33.5；64K dense 45.3、M3 37.2、B 36.1；AIME dense 30.7、M3 31.4。</a:t>
-            </a:r>
-          </a:p>
-          <a:p>
-            <a:r>
-              <a:t>【还能挖的】canvas 追加（encoder 与 decoder 共享权重，可复用最后的选块图）约 −1.4%（64K）；剩余观测/决策开销约 −1–2%。</a:t>
+              <a:t>【协议】v27_lb64_vterm_e9_5b125c63817898f6（specs/v27_lb64_vterm_e9.json），代码 efea33024（新增 k12 档位与单元测试），部署 v27_e9_efea330；576/576 次运行成功，每格同机，计时中无新图。</a:t>
+            </a:r>
+          </a:p>
+          <a:p>
+            <a:r>
+              <a:t>【收据核对】每次运行的 effective_method 都是预定配置（k12；proj_rank 8；risk_value=mass；M2 为 pooled_compact，20,225 次块均值构建；carry0 生效 5,115–5,315 次/臂；dense 引导只在 canvas 0，共 480 次）。</a:t>
+            </a:r>
+          </a:p>
+          <a:p>
+            <a:r>
+              <a:t>【可复现性】dense 和 −ln2 + carry0 两臂在这 96 格上与 E5 逐 token 相同（96/96）。</a:t>
+            </a:r>
+          </a:p>
+          <a:p>
+            <a:r>
+              <a:t>【数据路径】results/m1_m2_m3_frontier_v27_20260929/lb64_vterm_panel_e9/summary.md、receipts.md</a:t>
             </a:r>
           </a:p>
         </p:txBody>
@@ -1115,17 +1186,27 @@
           <a:lstStyle/>
           <a:p>
             <a:r>
-              <a:t>【脚本】scripts/v27_batch_step_bench.py（提交 02eead519），dlm2，E4 运行目录与部署；数据 results/m1_m2_m3_frontier_v27_20260929/batch_scaling/。</a:t>
-            </a:r>
-          </a:p>
-          <a:p>
-            <a:r>
-              <a:t>【口径】eager 的整次 decoder forward（含每次调用的 K/V 拼接，1.2/2.4/4.7 ms）一次性 CUDA graph 捕获后重放，CUDA event 取 15 次中位数；采样另测 2.5/4.8/9.4 ms。</a:t>
-            </a:r>
-          </a:p>
-          <a:p>
-            <a:r>
-              <a:t>【局限】只测了 64K 一个状态；batch 8 时复制的 64K 缓存放不下；合成保留图、不含选块开销；不是端到端，也不是真实服务。</a:t>
+              <a:t>【每步构成】（32K dense，substrate/time_breakdown.json，v2 时期，KV 拼接已在 v3 去掉）forward 约 32 ms：MoE 专家矩阵乘 12.8 ms、GLOBAL 注意力 7.2 ms、其余矩阵乘 3.5 ms、LOCAL 0.8 ms、其他约 4 ms；另有采样约 4.6 ms。</a:t>
+            </a:r>
+          </a:p>
+          <a:p>
+            <a:r>
+              <a:t>【MoE】128 个专家、每 token 选 8 个；一步 256 个 canvas token × 8 = 2048 次分配，几乎所有专家都会被用到，所以每步要读全部专家权重（约 46 GB），12.8 ms 已接近 H100 的 HBM 带宽极限。</a:t>
+            </a:r>
+          </a:p>
+          <a:p>
+            <a:r>
+              <a:t>【GLOBAL 注意力】CUDA event 直接计时（kernel_bench/module_profile_*）：dense 每层 1.46 ms（32K）/ 2.95 ms（64K）；M3 R6 DP −ln2 摊到每步：32K 4.3 ms、64K 5.5 ms（dense 7.3 / 14.75 ms）。</a:t>
+            </a:r>
+          </a:p>
+          <a:p>
+            <a:r>
+              <a:t>【每步解码时间】（摊销，72 格平均）32K dense 37.3 ms、M3 34.7、B 33.5；64K dense 45.3、M3 37.2、B 36.1；AIME dense 30.7、M3 31.4。</a:t>
+            </a:r>
+          </a:p>
+          <a:p>
+            <a:r>
+              <a:t>【还能挖的】canvas 追加（encoder 与 decoder 共享权重，可复用最后的选块图）约 −1.4%（64K）；剩余观测/决策开销约 −1–2%。</a:t>
             </a:r>
           </a:p>
         </p:txBody>
@@ -1195,12 +1276,17 @@
           <a:lstStyle/>
           <a:p>
             <a:r>
-              <a:t>【组内证据（不是我们的，只引用）】JunyuLiao 的 value-direction 选块维度扫描（分支 ljy/value_aware，提交 8b29f942d、47c47d9d7）：RULER8K 稀疏度约 75% 时，V 投影 32 维 47.4%、全维 49.8%、只看注意力质量 21.3%、2 维 2.5%；50% 时都约 92%。他的选块用当前 QK，与我们的历史 QK 不同。</a:t>
-            </a:r>
-          </a:p>
-          <a:p>
-            <a:r>
-              <a:t>【可能的论文方向】(1) 评测方法学：自适应停止下 dLLM 加速需要大样本（dense 对照方差、本次 E4 推翻 3 seed 结论）；(2) 看 V 选块（E8 在 AIME 上为否，取决于 64K 的 E9）；(3) 与同学的 query 敏感度方向合作。批量服务方向在 64K、batch ≤ 4 时没有放大收益（见上一页）。</a:t>
+              <a:t>【脚本】scripts/v27_batch_step_bench.py（提交 02eead519），dlm2，E4 运行目录与部署；数据 results/m1_m2_m3_frontier_v27_20260929/batch_scaling/。</a:t>
+            </a:r>
+          </a:p>
+          <a:p>
+            <a:r>
+              <a:t>【口径】eager 的整次 decoder forward（含每次调用的 K/V 拼接，1.2/2.4/4.7 ms）一次性 CUDA graph 捕获后重放，CUDA event 取 15 次中位数；采样另测 2.5/4.8/9.4 ms。</a:t>
+            </a:r>
+          </a:p>
+          <a:p>
+            <a:r>
+              <a:t>【局限】只测了 64K 一个状态；batch 8 时复制的 64K 缓存放不下；合成保留图、不含选块开销；不是端到端，也不是真实服务。</a:t>
             </a:r>
           </a:p>
         </p:txBody>
@@ -4289,6 +4375,548 @@
 </p:sld>
 </file>
 
+<file path=ppt/slides/slide10.xml><?xml version="1.0" encoding="utf-8"?>
+<p:sld xmlns:a="http://schemas.openxmlformats.org/drawingml/2006/main" xmlns:p="http://schemas.openxmlformats.org/presentationml/2006/main" xmlns:r="http://schemas.openxmlformats.org/officeDocument/2006/relationships">
+  <p:cSld>
+    <p:spTree>
+      <p:nvGrpSpPr>
+        <p:cNvPr id="1" name=""/>
+        <p:cNvGrpSpPr/>
+        <p:nvPr/>
+      </p:nvGrpSpPr>
+      <p:grpSpPr/>
+      <p:sp>
+        <p:nvSpPr>
+          <p:cNvPr id="2" name="TextBox 1"/>
+          <p:cNvSpPr txBox="1"/>
+          <p:nvPr/>
+        </p:nvSpPr>
+        <p:spPr>
+          <a:xfrm>
+            <a:off x="457200" y="274320"/>
+            <a:ext cx="11247120" cy="640080"/>
+          </a:xfrm>
+          <a:prstGeom prst="rect">
+            <a:avLst/>
+          </a:prstGeom>
+          <a:noFill/>
+        </p:spPr>
+        <p:txBody>
+          <a:bodyPr wrap="square">
+            <a:spAutoFit/>
+          </a:bodyPr>
+          <a:lstStyle/>
+          <a:p>
+            <a:pPr>
+              <a:spcAft>
+                <a:spcPts val="400"/>
+              </a:spcAft>
+            </a:pPr>
+            <a:r>
+              <a:rPr sz="2400" b="1">
+                <a:latin typeface="Microsoft YaHei"/>
+              </a:rPr>
+              <a:t>相关工作与新颖性现状</a:t>
+            </a:r>
+          </a:p>
+        </p:txBody>
+      </p:sp>
+      <p:sp>
+        <p:nvSpPr>
+          <p:cNvPr id="3" name="TextBox 2"/>
+          <p:cNvSpPr txBox="1"/>
+          <p:nvPr/>
+        </p:nvSpPr>
+        <p:spPr>
+          <a:xfrm>
+            <a:off x="457200" y="868680"/>
+            <a:ext cx="11247120" cy="548640"/>
+          </a:xfrm>
+          <a:prstGeom prst="rect">
+            <a:avLst/>
+          </a:prstGeom>
+          <a:noFill/>
+        </p:spPr>
+        <p:txBody>
+          <a:bodyPr wrap="square">
+            <a:spAutoFit/>
+          </a:bodyPr>
+          <a:lstStyle/>
+          <a:p>
+            <a:pPr>
+              <a:spcAft>
+                <a:spcPts val="400"/>
+              </a:spcAft>
+            </a:pPr>
+            <a:r>
+              <a:rPr sz="1200" b="0">
+                <a:solidFill>
+                  <a:srgbClr val="555555"/>
+                </a:solidFill>
+                <a:latin typeface="Microsoft YaHei"/>
+              </a:rPr>
+              <a:t>2026-10-01 复核论文摘要/正文 · 组内工作只引用</a:t>
+            </a:r>
+          </a:p>
+        </p:txBody>
+      </p:sp>
+      <p:graphicFrame>
+        <p:nvGraphicFramePr>
+          <p:cNvPr id="4" name="Table 3"/>
+          <p:cNvGraphicFramePr>
+            <a:graphicFrameLocks noGrp="1"/>
+          </p:cNvGraphicFramePr>
+          <p:nvPr/>
+        </p:nvGraphicFramePr>
+        <p:xfrm>
+          <a:off x="365760" y="1463040"/>
+          <a:ext cx="11430000" cy="2194560"/>
+        </p:xfrm>
+        <a:graphic>
+          <a:graphicData uri="http://schemas.openxmlformats.org/drawingml/2006/table">
+            <a:tbl>
+              <a:tblPr firstRow="1" bandRow="1">
+                <a:tableStyleId>{5C22544A-7EE6-4342-B048-85BDC9FD1C3A}</a:tableStyleId>
+              </a:tblPr>
+              <a:tblGrid>
+                <a:gridCol w="2377440"/>
+                <a:gridCol w="3474720"/>
+                <a:gridCol w="2743200"/>
+                <a:gridCol w="2834640"/>
+              </a:tblGrid>
+              <a:tr h="365760">
+                <a:tc>
+                  <a:txBody>
+                    <a:bodyPr/>
+                    <a:lstStyle/>
+                    <a:p>
+                      <a:r>
+                        <a:rPr sz="1200" b="1">
+                          <a:latin typeface="Microsoft YaHei"/>
+                        </a:rPr>
+                        <a:t>工作</a:t>
+                      </a:r>
+                    </a:p>
+                  </a:txBody>
+                  <a:tcPr/>
+                </a:tc>
+                <a:tc>
+                  <a:txBody>
+                    <a:bodyPr/>
+                    <a:lstStyle/>
+                    <a:p>
+                      <a:r>
+                        <a:rPr sz="1200" b="1">
+                          <a:latin typeface="Microsoft YaHei"/>
+                        </a:rPr>
+                        <a:t>做法</a:t>
+                      </a:r>
+                    </a:p>
+                  </a:txBody>
+                  <a:tcPr/>
+                </a:tc>
+                <a:tc>
+                  <a:txBody>
+                    <a:bodyPr/>
+                    <a:lstStyle/>
+                    <a:p>
+                      <a:r>
+                        <a:rPr sz="1200" b="1">
+                          <a:latin typeface="Microsoft YaHei"/>
+                        </a:rPr>
+                        <a:t>设置</a:t>
+                      </a:r>
+                    </a:p>
+                  </a:txBody>
+                  <a:tcPr/>
+                </a:tc>
+                <a:tc>
+                  <a:txBody>
+                    <a:bodyPr/>
+                    <a:lstStyle/>
+                    <a:p>
+                      <a:r>
+                        <a:rPr sz="1200" b="1">
+                          <a:latin typeface="Microsoft YaHei"/>
+                        </a:rPr>
+                        <a:t>与我们的关系</a:t>
+                      </a:r>
+                    </a:p>
+                  </a:txBody>
+                  <a:tcPr/>
+                </a:tc>
+              </a:tr>
+              <a:tr h="365760">
+                <a:tc>
+                  <a:txBody>
+                    <a:bodyPr/>
+                    <a:lstStyle/>
+                    <a:p>
+                      <a:r>
+                        <a:rPr sz="1200" b="0">
+                          <a:latin typeface="Microsoft YaHei"/>
+                        </a:rPr>
+                        <a:t>SparseD（ICLR 2026）</a:t>
+                      </a:r>
+                    </a:p>
+                  </a:txBody>
+                  <a:tcPr/>
+                </a:tc>
+                <a:tc>
+                  <a:txBody>
+                    <a:bodyPr/>
+                    <a:lstStyle/>
+                    <a:p>
+                      <a:r>
+                        <a:rPr sz="1200" b="0">
+                          <a:latin typeface="Microsoft YaHei"/>
+                        </a:rPr>
+                        <a:t>前若干步 dense，再按池化分数选块并复用</a:t>
+                      </a:r>
+                    </a:p>
+                  </a:txBody>
+                  <a:tcPr/>
+                </a:tc>
+                <a:tc>
+                  <a:txBody>
+                    <a:bodyPr/>
+                    <a:lstStyle/>
+                    <a:p>
+                      <a:r>
+                        <a:rPr sz="1200" b="0">
+                          <a:latin typeface="Microsoft YaHei"/>
+                        </a:rPr>
+                        <a:t>LLaDA/Dream，固定步数</a:t>
+                      </a:r>
+                    </a:p>
+                  </a:txBody>
+                  <a:tcPr/>
+                </a:tc>
+                <a:tc>
+                  <a:txBody>
+                    <a:bodyPr/>
+                    <a:lstStyle/>
+                    <a:p>
+                      <a:r>
+                        <a:rPr sz="1200" b="0">
+                          <a:latin typeface="Microsoft YaHei"/>
+                        </a:rPr>
+                        <a:t>≈ B，撞车；同 kernel 正面对比速度无显著差别</a:t>
+                      </a:r>
+                    </a:p>
+                  </a:txBody>
+                  <a:tcPr/>
+                </a:tc>
+              </a:tr>
+              <a:tr h="365760">
+                <a:tc>
+                  <a:txBody>
+                    <a:bodyPr/>
+                    <a:lstStyle/>
+                    <a:p>
+                      <a:r>
+                        <a:rPr sz="1200" b="0">
+                          <a:latin typeface="Microsoft YaHei"/>
+                        </a:rPr>
+                        <a:t>MAGE（2602.14209）</a:t>
+                      </a:r>
+                    </a:p>
+                  </a:txBody>
+                  <a:tcPr/>
+                </a:tc>
+                <a:tc>
+                  <a:txBody>
+                    <a:bodyPr/>
+                    <a:lstStyle/>
+                    <a:p>
+                      <a:r>
+                        <a:rPr sz="1200" b="0">
+                          <a:latin typeface="Microsoft YaHei"/>
+                        </a:rPr>
+                        <a:t>块的第一步精确注意力选 top-k，整块复用；副流异步</a:t>
+                      </a:r>
+                    </a:p>
+                  </a:txBody>
+                  <a:tcPr/>
+                </a:tc>
+                <a:tc>
+                  <a:txBody>
+                    <a:bodyPr/>
+                    <a:lstStyle/>
+                    <a:p>
+                      <a:r>
+                        <a:rPr sz="1200" b="0">
+                          <a:latin typeface="Microsoft YaHei"/>
+                        </a:rPr>
+                        <a:t>7–8B 块扩散，32 token 块 × 固定 32 步，128K 6.82×</a:t>
+                      </a:r>
+                    </a:p>
+                  </a:txBody>
+                  <a:tcPr/>
+                </a:tc>
+                <a:tc>
+                  <a:txBody>
+                    <a:bodyPr/>
+                    <a:lstStyle/>
+                    <a:p>
+                      <a:r>
+                        <a:rPr sz="1200" b="0">
+                          <a:latin typeface="Microsoft YaHei"/>
+                        </a:rPr>
+                        <a:t>≈ B（撞车）；大倍数来自 dense 小模型 + 128K</a:t>
+                      </a:r>
+                    </a:p>
+                  </a:txBody>
+                  <a:tcPr/>
+                </a:tc>
+              </a:tr>
+              <a:tr h="365760">
+                <a:tc>
+                  <a:txBody>
+                    <a:bodyPr/>
+                    <a:lstStyle/>
+                    <a:p>
+                      <a:r>
+                        <a:rPr sz="1200" b="0">
+                          <a:latin typeface="Microsoft YaHei"/>
+                        </a:rPr>
+                        <a:t>HERALD（2606.21633）</a:t>
+                      </a:r>
+                    </a:p>
+                  </a:txBody>
+                  <a:tcPr/>
+                </a:tc>
+                <a:tc>
+                  <a:txBody>
+                    <a:bodyPr/>
+                    <a:lstStyle/>
+                    <a:p>
+                      <a:r>
+                        <a:rPr sz="1200" b="0">
+                          <a:latin typeface="Microsoft YaHei"/>
+                        </a:rPr>
+                        <a:t>批量块扩散服务：每块选一次 KV，CPU-GPU 协同取 KV</a:t>
+                      </a:r>
+                    </a:p>
+                  </a:txBody>
+                  <a:tcPr/>
+                </a:tc>
+                <a:tc>
+                  <a:txBody>
+                    <a:bodyPr/>
+                    <a:lstStyle/>
+                    <a:p>
+                      <a:r>
+                        <a:rPr sz="1200" b="0">
+                          <a:latin typeface="Microsoft YaHei"/>
+                        </a:rPr>
+                        <a:t>解码吞吐 2.28×，5% KV 预算</a:t>
+                      </a:r>
+                    </a:p>
+                  </a:txBody>
+                  <a:tcPr/>
+                </a:tc>
+                <a:tc>
+                  <a:txBody>
+                    <a:bodyPr/>
+                    <a:lstStyle/>
+                    <a:p>
+                      <a:r>
+                        <a:rPr sz="1200" b="0">
+                          <a:latin typeface="Microsoft YaHei"/>
+                        </a:rPr>
+                        <a:t>批量服务方向的直接相关工作</a:t>
+                      </a:r>
+                    </a:p>
+                  </a:txBody>
+                  <a:tcPr/>
+                </a:tc>
+              </a:tr>
+              <a:tr h="365760">
+                <a:tc>
+                  <a:txBody>
+                    <a:bodyPr/>
+                    <a:lstStyle/>
+                    <a:p>
+                      <a:r>
+                        <a:rPr sz="1200" b="0">
+                          <a:latin typeface="Microsoft YaHei"/>
+                        </a:rPr>
+                        <a:t>PulseCol / Focus-dLLM / LoSA</a:t>
+                      </a:r>
+                    </a:p>
+                  </a:txBody>
+                  <a:tcPr/>
+                </a:tc>
+                <a:tc>
+                  <a:txBody>
+                    <a:bodyPr/>
+                    <a:lstStyle/>
+                    <a:p>
+                      <a:r>
+                        <a:rPr sz="1200" b="0">
+                          <a:latin typeface="Microsoft YaHei"/>
+                        </a:rPr>
+                        <a:t>周期刷新 / 按置信度裁剪 / 稳定 token 复用</a:t>
+                      </a:r>
+                    </a:p>
+                  </a:txBody>
+                  <a:tcPr/>
+                </a:tc>
+                <a:tc>
+                  <a:txBody>
+                    <a:bodyPr/>
+                    <a:lstStyle/>
+                    <a:p>
+                      <a:r>
+                        <a:rPr sz="1200" b="0">
+                          <a:latin typeface="Microsoft YaHei"/>
+                        </a:rPr>
+                        <a:t>固定步数或长度</a:t>
+                      </a:r>
+                    </a:p>
+                  </a:txBody>
+                  <a:tcPr/>
+                </a:tc>
+                <a:tc>
+                  <a:txBody>
+                    <a:bodyPr/>
+                    <a:lstStyle/>
+                    <a:p>
+                      <a:r>
+                        <a:rPr sz="1200" b="0">
+                          <a:latin typeface="Microsoft YaHei"/>
+                        </a:rPr>
+                        <a:t>部分相关</a:t>
+                      </a:r>
+                    </a:p>
+                  </a:txBody>
+                  <a:tcPr/>
+                </a:tc>
+              </a:tr>
+              <a:tr h="365760">
+                <a:tc>
+                  <a:txBody>
+                    <a:bodyPr/>
+                    <a:lstStyle/>
+                    <a:p>
+                      <a:r>
+                        <a:rPr sz="1200" b="0">
+                          <a:latin typeface="Microsoft YaHei"/>
+                        </a:rPr>
+                        <a:t>Lil / LessIsMore</a:t>
+                      </a:r>
+                    </a:p>
+                  </a:txBody>
+                  <a:tcPr/>
+                </a:tc>
+                <a:tc>
+                  <a:txBody>
+                    <a:bodyPr/>
+                    <a:lstStyle/>
+                    <a:p>
+                      <a:r>
+                        <a:rPr sz="1200" b="0">
+                          <a:latin typeface="Microsoft YaHei"/>
+                        </a:rPr>
+                        <a:t>稀疏注意力导致推理输出变长</a:t>
+                      </a:r>
+                    </a:p>
+                  </a:txBody>
+                  <a:tcPr/>
+                </a:tc>
+                <a:tc>
+                  <a:txBody>
+                    <a:bodyPr/>
+                    <a:lstStyle/>
+                    <a:p>
+                      <a:r>
+                        <a:rPr sz="1200" b="0">
+                          <a:latin typeface="Microsoft YaHei"/>
+                        </a:rPr>
+                        <a:t>自回归推理模型</a:t>
+                      </a:r>
+                    </a:p>
+                  </a:txBody>
+                  <a:tcPr/>
+                </a:tc>
+                <a:tc>
+                  <a:txBody>
+                    <a:bodyPr/>
+                    <a:lstStyle/>
+                    <a:p>
+                      <a:r>
+                        <a:rPr sz="1200" b="0">
+                          <a:latin typeface="Microsoft YaHei"/>
+                        </a:rPr>
+                        <a:t>我们在大样本下没有观察到输出变长</a:t>
+                      </a:r>
+                    </a:p>
+                  </a:txBody>
+                  <a:tcPr/>
+                </a:tc>
+              </a:tr>
+            </a:tbl>
+          </a:graphicData>
+        </a:graphic>
+      </p:graphicFrame>
+      <p:sp>
+        <p:nvSpPr>
+          <p:cNvPr id="5" name="TextBox 4"/>
+          <p:cNvSpPr txBox="1"/>
+          <p:nvPr/>
+        </p:nvSpPr>
+        <p:spPr>
+          <a:xfrm>
+            <a:off x="365760" y="3794760"/>
+            <a:ext cx="11430000" cy="2286000"/>
+          </a:xfrm>
+          <a:prstGeom prst="rect">
+            <a:avLst/>
+          </a:prstGeom>
+          <a:noFill/>
+        </p:spPr>
+        <p:txBody>
+          <a:bodyPr wrap="square">
+            <a:spAutoFit/>
+          </a:bodyPr>
+          <a:lstStyle/>
+          <a:p>
+            <a:pPr>
+              <a:spcAft>
+                <a:spcPts val="400"/>
+              </a:spcAft>
+            </a:pPr>
+            <a:r>
+              <a:rPr sz="1400" b="0">
+                <a:latin typeface="Microsoft YaHei"/>
+              </a:rPr>
+              <a:t>• "每块选一次、复用"已被 SparseD / MAGE / HERALD 覆盖；"看 V 的选块更好"没有数据支持（E8 AIME、E9 64K：无 V 项优于只看注意力质量）。</a:t>
+            </a:r>
+          </a:p>
+          <a:p>
+            <a:pPr>
+              <a:spcAft>
+                <a:spcPts val="400"/>
+              </a:spcAft>
+            </a:pPr>
+            <a:r>
+              <a:rPr sz="1400" b="0">
+                <a:latin typeface="Microsoft YaHei"/>
+              </a:rPr>
+              <a:t>• 站得住的：生产级 MoE dLLM + 原生自适应停止 + 最强官方基线 + 大样本协议下的端到端收益与精度，以及成本结构分析。</a:t>
+            </a:r>
+          </a:p>
+        </p:txBody>
+      </p:sp>
+    </p:spTree>
+  </p:cSld>
+  <p:clrMapOvr>
+    <a:masterClrMapping/>
+  </p:clrMapOvr>
+</p:sld>
+</file>
+
 <file path=ppt/slides/slide2.xml><?xml version="1.0" encoding="utf-8"?>
 <p:sld xmlns:a="http://schemas.openxmlformats.org/drawingml/2006/main" xmlns:p="http://schemas.openxmlformats.org/presentationml/2006/main" xmlns:r="http://schemas.openxmlformats.org/officeDocument/2006/relationships">
   <p:cSld>
@@ -8143,7 +8771,7 @@
               <a:rPr sz="1400" b="0">
                 <a:latin typeface="Microsoft YaHei"/>
               </a:rPr>
-              <a:t>• 结论：AIME 上“看 V 选块”的新颖性主张不成立；64K 同类对照（E9，M3 + carry0，固定 88% 稀疏度）今晚出结果。</a:t>
+              <a:t>• 结论：AIME 上“看 V 选块”的新颖性主张不成立；64K 的同类对照（E9，下一页）结论相同。</a:t>
             </a:r>
           </a:p>
         </p:txBody>
@@ -8157,6 +8785,743 @@
 </file>
 
 <file path=ppt/slides/slide7.xml><?xml version="1.0" encoding="utf-8"?>
+<p:sld xmlns:a="http://schemas.openxmlformats.org/drawingml/2006/main" xmlns:p="http://schemas.openxmlformats.org/presentationml/2006/main" xmlns:r="http://schemas.openxmlformats.org/officeDocument/2006/relationships">
+  <p:cSld>
+    <p:spTree>
+      <p:nvGrpSpPr>
+        <p:cNvPr id="1" name=""/>
+        <p:cNvGrpSpPr/>
+        <p:nvPr/>
+      </p:nvGrpSpPr>
+      <p:grpSpPr/>
+      <p:sp>
+        <p:nvSpPr>
+          <p:cNvPr id="2" name="TextBox 1"/>
+          <p:cNvSpPr txBox="1"/>
+          <p:nvPr/>
+        </p:nvSpPr>
+        <p:spPr>
+          <a:xfrm>
+            <a:off x="457200" y="274320"/>
+            <a:ext cx="11247120" cy="640080"/>
+          </a:xfrm>
+          <a:prstGeom prst="rect">
+            <a:avLst/>
+          </a:prstGeom>
+          <a:noFill/>
+        </p:spPr>
+        <p:txBody>
+          <a:bodyPr wrap="square">
+            <a:spAutoFit/>
+          </a:bodyPr>
+          <a:lstStyle/>
+          <a:p>
+            <a:pPr>
+              <a:spcAft>
+                <a:spcPts val="400"/>
+              </a:spcAft>
+            </a:pPr>
+            <a:r>
+              <a:rPr sz="2400" b="1">
+                <a:latin typeface="Microsoft YaHei"/>
+              </a:rPr>
+              <a:t>64K 上看 V 也没有帮助（E9，M3 + carry0，固定 88% 稀疏度）：只看注意力质量一样准、一样快</a:t>
+            </a:r>
+          </a:p>
+        </p:txBody>
+      </p:sp>
+      <p:sp>
+        <p:nvSpPr>
+          <p:cNvPr id="3" name="TextBox 2"/>
+          <p:cNvSpPr txBox="1"/>
+          <p:nvPr/>
+        </p:nvSpPr>
+        <p:spPr>
+          <a:xfrm>
+            <a:off x="457200" y="868680"/>
+            <a:ext cx="11247120" cy="548640"/>
+          </a:xfrm>
+          <a:prstGeom prst="rect">
+            <a:avLst/>
+          </a:prstGeom>
+          <a:noFill/>
+        </p:spPr>
+        <p:txBody>
+          <a:bodyPr wrap="square">
+            <a:spAutoFit/>
+          </a:bodyPr>
+          <a:lstStyle/>
+          <a:p>
+            <a:pPr>
+              <a:spcAft>
+                <a:spcPts val="400"/>
+              </a:spcAft>
+            </a:pPr>
+            <a:r>
+              <a:rPr sz="1200" b="0">
+                <a:solidFill>
+                  <a:srgbClr val="555555"/>
+                </a:solidFill>
+                <a:latin typeface="Microsoft YaHei"/>
+              </a:rPr>
+              <a:t>LongBench-v2 64K 同 E4/E5 的 24 题 × 4 个 seed（404–707）= 96 格/方法 · 都是 M3 R6 DP + carry0，固定保留 12% 的 prefix 块，只换 V 项；−ln2 阈值版作工作点参照 · dense = FA4 · 底座 v5 · 同格同机</a:t>
+            </a:r>
+          </a:p>
+        </p:txBody>
+      </p:sp>
+      <p:graphicFrame>
+        <p:nvGraphicFramePr>
+          <p:cNvPr id="4" name="Table 3"/>
+          <p:cNvGraphicFramePr>
+            <a:graphicFrameLocks noGrp="1"/>
+          </p:cNvGraphicFramePr>
+          <p:nvPr/>
+        </p:nvGraphicFramePr>
+        <p:xfrm>
+          <a:off x="365760" y="1463040"/>
+          <a:ext cx="11429996" cy="2194560"/>
+        </p:xfrm>
+        <a:graphic>
+          <a:graphicData uri="http://schemas.openxmlformats.org/drawingml/2006/table">
+            <a:tbl>
+              <a:tblPr firstRow="1" bandRow="1">
+                <a:tableStyleId>{5C22544A-7EE6-4342-B048-85BDC9FD1C3A}</a:tableStyleId>
+              </a:tblPr>
+              <a:tblGrid>
+                <a:gridCol w="3153103"/>
+                <a:gridCol w="2561896"/>
+                <a:gridCol w="1379482"/>
+                <a:gridCol w="1379482"/>
+                <a:gridCol w="1182413"/>
+                <a:gridCol w="1773620"/>
+              </a:tblGrid>
+              <a:tr h="365760">
+                <a:tc>
+                  <a:txBody>
+                    <a:bodyPr/>
+                    <a:lstStyle/>
+                    <a:p>
+                      <a:r>
+                        <a:rPr sz="1200" b="1">
+                          <a:latin typeface="Microsoft YaHei"/>
+                        </a:rPr>
+                        <a:t>V 项</a:t>
+                      </a:r>
+                    </a:p>
+                  </a:txBody>
+                  <a:tcPr/>
+                </a:tc>
+                <a:tc>
+                  <a:txBody>
+                    <a:bodyPr/>
+                    <a:lstStyle/>
+                    <a:p>
+                      <a:r>
+                        <a:rPr sz="1200" b="1">
+                          <a:latin typeface="Microsoft YaHei"/>
+                        </a:rPr>
+                        <a:t>端到端 W [95% CI]</a:t>
+                      </a:r>
+                    </a:p>
+                  </a:txBody>
+                  <a:tcPr/>
+                </a:tc>
+                <a:tc>
+                  <a:txBody>
+                    <a:bodyPr/>
+                    <a:lstStyle/>
+                    <a:p>
+                      <a:r>
+                        <a:rPr sz="1200" b="1">
+                          <a:latin typeface="Microsoft YaHei"/>
+                        </a:rPr>
+                        <a:t>纯生成 S</a:t>
+                      </a:r>
+                    </a:p>
+                  </a:txBody>
+                  <a:tcPr/>
+                </a:tc>
+                <a:tc>
+                  <a:txBody>
+                    <a:bodyPr/>
+                    <a:lstStyle/>
+                    <a:p>
+                      <a:r>
+                        <a:rPr sz="1200" b="1">
+                          <a:latin typeface="Microsoft YaHei"/>
+                        </a:rPr>
+                        <a:t>每步 S/N</a:t>
+                      </a:r>
+                    </a:p>
+                  </a:txBody>
+                  <a:tcPr/>
+                </a:tc>
+                <a:tc>
+                  <a:txBody>
+                    <a:bodyPr/>
+                    <a:lstStyle/>
+                    <a:p>
+                      <a:r>
+                        <a:rPr sz="1200" b="1">
+                          <a:latin typeface="Microsoft YaHei"/>
+                        </a:rPr>
+                        <a:t>步数 N</a:t>
+                      </a:r>
+                    </a:p>
+                  </a:txBody>
+                  <a:tcPr/>
+                </a:tc>
+                <a:tc>
+                  <a:txBody>
+                    <a:bodyPr/>
+                    <a:lstStyle/>
+                    <a:p>
+                      <a:r>
+                        <a:rPr sz="1200" b="1">
+                          <a:latin typeface="Microsoft YaHei"/>
+                        </a:rPr>
+                        <a:t>答对（dense 51）</a:t>
+                      </a:r>
+                    </a:p>
+                  </a:txBody>
+                  <a:tcPr/>
+                </a:tc>
+              </a:tr>
+              <a:tr h="365760">
+                <a:tc>
+                  <a:txBody>
+                    <a:bodyPr/>
+                    <a:lstStyle/>
+                    <a:p>
+                      <a:r>
+                        <a:rPr sz="1200" b="0">
+                          <a:latin typeface="Microsoft YaHei"/>
+                        </a:rPr>
+                        <a:t>投影 V 32 维</a:t>
+                      </a:r>
+                    </a:p>
+                  </a:txBody>
+                  <a:tcPr/>
+                </a:tc>
+                <a:tc>
+                  <a:txBody>
+                    <a:bodyPr/>
+                    <a:lstStyle/>
+                    <a:p>
+                      <a:r>
+                        <a:rPr sz="1200" b="0">
+                          <a:latin typeface="Microsoft YaHei"/>
+                        </a:rPr>
+                        <a:t>0.880 [0.825, 0.932]</a:t>
+                      </a:r>
+                    </a:p>
+                  </a:txBody>
+                  <a:tcPr/>
+                </a:tc>
+                <a:tc>
+                  <a:txBody>
+                    <a:bodyPr/>
+                    <a:lstStyle/>
+                    <a:p>
+                      <a:r>
+                        <a:rPr sz="1200" b="0">
+                          <a:latin typeface="Microsoft YaHei"/>
+                        </a:rPr>
+                        <a:t>0.818</a:t>
+                      </a:r>
+                    </a:p>
+                  </a:txBody>
+                  <a:tcPr/>
+                </a:tc>
+                <a:tc>
+                  <a:txBody>
+                    <a:bodyPr/>
+                    <a:lstStyle/>
+                    <a:p>
+                      <a:r>
+                        <a:rPr sz="1200" b="0">
+                          <a:latin typeface="Microsoft YaHei"/>
+                        </a:rPr>
+                        <a:t>0.781</a:t>
+                      </a:r>
+                    </a:p>
+                  </a:txBody>
+                  <a:tcPr/>
+                </a:tc>
+                <a:tc>
+                  <a:txBody>
+                    <a:bodyPr/>
+                    <a:lstStyle/>
+                    <a:p>
+                      <a:r>
+                        <a:rPr sz="1200" b="0">
+                          <a:latin typeface="Microsoft YaHei"/>
+                        </a:rPr>
+                        <a:t>1.05</a:t>
+                      </a:r>
+                    </a:p>
+                  </a:txBody>
+                  <a:tcPr/>
+                </a:tc>
+                <a:tc>
+                  <a:txBody>
+                    <a:bodyPr/>
+                    <a:lstStyle/>
+                    <a:p>
+                      <a:r>
+                        <a:rPr sz="1200" b="0">
+                          <a:latin typeface="Microsoft YaHei"/>
+                        </a:rPr>
+                        <a:t>53</a:t>
+                      </a:r>
+                    </a:p>
+                  </a:txBody>
+                  <a:tcPr/>
+                </a:tc>
+              </a:tr>
+              <a:tr h="365760">
+                <a:tc>
+                  <a:txBody>
+                    <a:bodyPr/>
+                    <a:lstStyle/>
+                    <a:p>
+                      <a:r>
+                        <a:rPr sz="1200" b="0">
+                          <a:latin typeface="Microsoft YaHei"/>
+                        </a:rPr>
+                        <a:t>投影 V 8 维</a:t>
+                      </a:r>
+                    </a:p>
+                  </a:txBody>
+                  <a:tcPr/>
+                </a:tc>
+                <a:tc>
+                  <a:txBody>
+                    <a:bodyPr/>
+                    <a:lstStyle/>
+                    <a:p>
+                      <a:r>
+                        <a:rPr sz="1200" b="0">
+                          <a:latin typeface="Microsoft YaHei"/>
+                        </a:rPr>
+                        <a:t>0.854 [0.791, 0.924]</a:t>
+                      </a:r>
+                    </a:p>
+                  </a:txBody>
+                  <a:tcPr/>
+                </a:tc>
+                <a:tc>
+                  <a:txBody>
+                    <a:bodyPr/>
+                    <a:lstStyle/>
+                    <a:p>
+                      <a:r>
+                        <a:rPr sz="1200" b="0">
+                          <a:latin typeface="Microsoft YaHei"/>
+                        </a:rPr>
+                        <a:t>0.777</a:t>
+                      </a:r>
+                    </a:p>
+                  </a:txBody>
+                  <a:tcPr/>
+                </a:tc>
+                <a:tc>
+                  <a:txBody>
+                    <a:bodyPr/>
+                    <a:lstStyle/>
+                    <a:p>
+                      <a:r>
+                        <a:rPr sz="1200" b="0">
+                          <a:latin typeface="Microsoft YaHei"/>
+                        </a:rPr>
+                        <a:t>0.785</a:t>
+                      </a:r>
+                    </a:p>
+                  </a:txBody>
+                  <a:tcPr/>
+                </a:tc>
+                <a:tc>
+                  <a:txBody>
+                    <a:bodyPr/>
+                    <a:lstStyle/>
+                    <a:p>
+                      <a:r>
+                        <a:rPr sz="1200" b="0">
+                          <a:latin typeface="Microsoft YaHei"/>
+                        </a:rPr>
+                        <a:t>0.99</a:t>
+                      </a:r>
+                    </a:p>
+                  </a:txBody>
+                  <a:tcPr/>
+                </a:tc>
+                <a:tc>
+                  <a:txBody>
+                    <a:bodyPr/>
+                    <a:lstStyle/>
+                    <a:p>
+                      <a:r>
+                        <a:rPr sz="1200" b="0">
+                          <a:latin typeface="Microsoft YaHei"/>
+                        </a:rPr>
+                        <a:t>50</a:t>
+                      </a:r>
+                    </a:p>
+                  </a:txBody>
+                  <a:tcPr/>
+                </a:tc>
+              </a:tr>
+              <a:tr h="365760">
+                <a:tc>
+                  <a:txBody>
+                    <a:bodyPr/>
+                    <a:lstStyle/>
+                    <a:p>
+                      <a:r>
+                        <a:rPr sz="1200" b="0">
+                          <a:latin typeface="Microsoft YaHei"/>
+                        </a:rPr>
+                        <a:t>M2 块均值 V</a:t>
+                      </a:r>
+                    </a:p>
+                  </a:txBody>
+                  <a:tcPr/>
+                </a:tc>
+                <a:tc>
+                  <a:txBody>
+                    <a:bodyPr/>
+                    <a:lstStyle/>
+                    <a:p>
+                      <a:r>
+                        <a:rPr sz="1200" b="0">
+                          <a:latin typeface="Microsoft YaHei"/>
+                        </a:rPr>
+                        <a:t>0.888 [0.828, 0.948]</a:t>
+                      </a:r>
+                    </a:p>
+                  </a:txBody>
+                  <a:tcPr/>
+                </a:tc>
+                <a:tc>
+                  <a:txBody>
+                    <a:bodyPr/>
+                    <a:lstStyle/>
+                    <a:p>
+                      <a:r>
+                        <a:rPr sz="1200" b="0">
+                          <a:latin typeface="Microsoft YaHei"/>
+                        </a:rPr>
+                        <a:t>0.826</a:t>
+                      </a:r>
+                    </a:p>
+                  </a:txBody>
+                  <a:tcPr/>
+                </a:tc>
+                <a:tc>
+                  <a:txBody>
+                    <a:bodyPr/>
+                    <a:lstStyle/>
+                    <a:p>
+                      <a:r>
+                        <a:rPr sz="1200" b="0">
+                          <a:latin typeface="Microsoft YaHei"/>
+                        </a:rPr>
+                        <a:t>0.780</a:t>
+                      </a:r>
+                    </a:p>
+                  </a:txBody>
+                  <a:tcPr/>
+                </a:tc>
+                <a:tc>
+                  <a:txBody>
+                    <a:bodyPr/>
+                    <a:lstStyle/>
+                    <a:p>
+                      <a:r>
+                        <a:rPr sz="1200" b="0">
+                          <a:latin typeface="Microsoft YaHei"/>
+                        </a:rPr>
+                        <a:t>1.06</a:t>
+                      </a:r>
+                    </a:p>
+                  </a:txBody>
+                  <a:tcPr/>
+                </a:tc>
+                <a:tc>
+                  <a:txBody>
+                    <a:bodyPr/>
+                    <a:lstStyle/>
+                    <a:p>
+                      <a:r>
+                        <a:rPr sz="1200" b="0">
+                          <a:latin typeface="Microsoft YaHei"/>
+                        </a:rPr>
+                        <a:t>54</a:t>
+                      </a:r>
+                    </a:p>
+                  </a:txBody>
+                  <a:tcPr/>
+                </a:tc>
+              </a:tr>
+              <a:tr h="365760">
+                <a:tc>
+                  <a:txBody>
+                    <a:bodyPr/>
+                    <a:lstStyle/>
+                    <a:p>
+                      <a:r>
+                        <a:rPr sz="1200" b="0">
+                          <a:latin typeface="Microsoft YaHei"/>
+                        </a:rPr>
+                        <a:t>不看 V（只看注意力质量）</a:t>
+                      </a:r>
+                    </a:p>
+                  </a:txBody>
+                  <a:tcPr/>
+                </a:tc>
+                <a:tc>
+                  <a:txBody>
+                    <a:bodyPr/>
+                    <a:lstStyle/>
+                    <a:p>
+                      <a:r>
+                        <a:rPr sz="1200" b="0">
+                          <a:latin typeface="Microsoft YaHei"/>
+                        </a:rPr>
+                        <a:t>0.845 [0.789, 0.894]</a:t>
+                      </a:r>
+                    </a:p>
+                  </a:txBody>
+                  <a:tcPr/>
+                </a:tc>
+                <a:tc>
+                  <a:txBody>
+                    <a:bodyPr/>
+                    <a:lstStyle/>
+                    <a:p>
+                      <a:r>
+                        <a:rPr sz="1200" b="0">
+                          <a:latin typeface="Microsoft YaHei"/>
+                        </a:rPr>
+                        <a:t>0.772</a:t>
+                      </a:r>
+                    </a:p>
+                  </a:txBody>
+                  <a:tcPr/>
+                </a:tc>
+                <a:tc>
+                  <a:txBody>
+                    <a:bodyPr/>
+                    <a:lstStyle/>
+                    <a:p>
+                      <a:r>
+                        <a:rPr sz="1200" b="0">
+                          <a:latin typeface="Microsoft YaHei"/>
+                        </a:rPr>
+                        <a:t>0.784</a:t>
+                      </a:r>
+                    </a:p>
+                  </a:txBody>
+                  <a:tcPr/>
+                </a:tc>
+                <a:tc>
+                  <a:txBody>
+                    <a:bodyPr/>
+                    <a:lstStyle/>
+                    <a:p>
+                      <a:r>
+                        <a:rPr sz="1200" b="0">
+                          <a:latin typeface="Microsoft YaHei"/>
+                        </a:rPr>
+                        <a:t>0.99</a:t>
+                      </a:r>
+                    </a:p>
+                  </a:txBody>
+                  <a:tcPr/>
+                </a:tc>
+                <a:tc>
+                  <a:txBody>
+                    <a:bodyPr/>
+                    <a:lstStyle/>
+                    <a:p>
+                      <a:r>
+                        <a:rPr sz="1200" b="0">
+                          <a:latin typeface="Microsoft YaHei"/>
+                        </a:rPr>
+                        <a:t>54</a:t>
+                      </a:r>
+                    </a:p>
+                  </a:txBody>
+                  <a:tcPr/>
+                </a:tc>
+              </a:tr>
+              <a:tr h="365760">
+                <a:tc>
+                  <a:txBody>
+                    <a:bodyPr/>
+                    <a:lstStyle/>
+                    <a:p>
+                      <a:r>
+                        <a:rPr sz="1200" b="0">
+                          <a:latin typeface="Microsoft YaHei"/>
+                        </a:rPr>
+                        <a:t>−ln2 阈值版（当前最好）</a:t>
+                      </a:r>
+                    </a:p>
+                  </a:txBody>
+                  <a:tcPr/>
+                </a:tc>
+                <a:tc>
+                  <a:txBody>
+                    <a:bodyPr/>
+                    <a:lstStyle/>
+                    <a:p>
+                      <a:r>
+                        <a:rPr sz="1200" b="0">
+                          <a:latin typeface="Microsoft YaHei"/>
+                        </a:rPr>
+                        <a:t>0.846 [0.781, 0.894]</a:t>
+                      </a:r>
+                    </a:p>
+                  </a:txBody>
+                  <a:tcPr/>
+                </a:tc>
+                <a:tc>
+                  <a:txBody>
+                    <a:bodyPr/>
+                    <a:lstStyle/>
+                    <a:p>
+                      <a:r>
+                        <a:rPr sz="1200" b="0">
+                          <a:latin typeface="Microsoft YaHei"/>
+                        </a:rPr>
+                        <a:t>0.768</a:t>
+                      </a:r>
+                    </a:p>
+                  </a:txBody>
+                  <a:tcPr/>
+                </a:tc>
+                <a:tc>
+                  <a:txBody>
+                    <a:bodyPr/>
+                    <a:lstStyle/>
+                    <a:p>
+                      <a:r>
+                        <a:rPr sz="1200" b="0">
+                          <a:latin typeface="Microsoft YaHei"/>
+                        </a:rPr>
+                        <a:t>0.816</a:t>
+                      </a:r>
+                    </a:p>
+                  </a:txBody>
+                  <a:tcPr/>
+                </a:tc>
+                <a:tc>
+                  <a:txBody>
+                    <a:bodyPr/>
+                    <a:lstStyle/>
+                    <a:p>
+                      <a:r>
+                        <a:rPr sz="1200" b="0">
+                          <a:latin typeface="Microsoft YaHei"/>
+                        </a:rPr>
+                        <a:t>0.94</a:t>
+                      </a:r>
+                    </a:p>
+                  </a:txBody>
+                  <a:tcPr/>
+                </a:tc>
+                <a:tc>
+                  <a:txBody>
+                    <a:bodyPr/>
+                    <a:lstStyle/>
+                    <a:p>
+                      <a:r>
+                        <a:rPr sz="1200" b="0">
+                          <a:latin typeface="Microsoft YaHei"/>
+                        </a:rPr>
+                        <a:t>49</a:t>
+                      </a:r>
+                    </a:p>
+                  </a:txBody>
+                  <a:tcPr/>
+                </a:tc>
+              </a:tr>
+            </a:tbl>
+          </a:graphicData>
+        </a:graphic>
+      </p:graphicFrame>
+      <p:sp>
+        <p:nvSpPr>
+          <p:cNvPr id="5" name="TextBox 4"/>
+          <p:cNvSpPr txBox="1"/>
+          <p:nvPr/>
+        </p:nvSpPr>
+        <p:spPr>
+          <a:xfrm>
+            <a:off x="365760" y="3794760"/>
+            <a:ext cx="11430000" cy="2286000"/>
+          </a:xfrm>
+          <a:prstGeom prst="rect">
+            <a:avLst/>
+          </a:prstGeom>
+          <a:noFill/>
+        </p:spPr>
+        <p:txBody>
+          <a:bodyPr wrap="square">
+            <a:spAutoFit/>
+          </a:bodyPr>
+          <a:lstStyle/>
+          <a:p>
+            <a:pPr>
+              <a:spcAft>
+                <a:spcPts val="400"/>
+              </a:spcAft>
+            </a:pPr>
+            <a:r>
+              <a:rPr sz="1400" b="0">
+                <a:latin typeface="Microsoft YaHei"/>
+              </a:rPr>
+              <a:t>• 64K 上任何 V 项都不比“只看注意力质量”更准（50–54 vs 51，全部不显著），速度也无显著差别（只看质量 / 32 维 0.960 [0.905, 1.018]）。</a:t>
+            </a:r>
+          </a:p>
+          <a:p>
+            <a:pPr>
+              <a:spcAft>
+                <a:spcPts val="400"/>
+              </a:spcAft>
+            </a:pPr>
+            <a:r>
+              <a:rPr sz="1400" b="0">
+                <a:latin typeface="Microsoft YaHei"/>
+              </a:rPr>
+              <a:t>• 每步成本几乎不随 V 项变化（0.780–0.785）：投影 V 不贵，但也没换来更好的选块。</a:t>
+            </a:r>
+          </a:p>
+          <a:p>
+            <a:pPr>
+              <a:spcAft>
+                <a:spcPts val="400"/>
+              </a:spcAft>
+            </a:pPr>
+            <a:r>
+              <a:rPr sz="1400" b="0">
+                <a:latin typeface="Microsoft YaHei"/>
+              </a:rPr>
+              <a:t>• 结合 E8：“看 V 选块”不能作为贡献；选块器可去掉 V 项而不损失，更接近 SparseD 一类只看分数的方法。</a:t>
+            </a:r>
+          </a:p>
+        </p:txBody>
+      </p:sp>
+    </p:spTree>
+  </p:cSld>
+  <p:clrMapOvr>
+    <a:masterClrMapping/>
+  </p:clrMapOvr>
+</p:sld>
+</file>
+
+<file path=ppt/slides/slide8.xml><?xml version="1.0" encoding="utf-8"?>
 <p:sld xmlns:a="http://schemas.openxmlformats.org/drawingml/2006/main" xmlns:p="http://schemas.openxmlformats.org/presentationml/2006/main" xmlns:r="http://schemas.openxmlformats.org/officeDocument/2006/relationships">
   <p:cSld>
     <p:spTree>
@@ -8698,7 +10063,7 @@
 </p:sld>
 </file>
 
-<file path=ppt/slides/slide8.xml><?xml version="1.0" encoding="utf-8"?>
+<file path=ppt/slides/slide9.xml><?xml version="1.0" encoding="utf-8"?>
 <p:sld xmlns:a="http://schemas.openxmlformats.org/drawingml/2006/main" xmlns:p="http://schemas.openxmlformats.org/presentationml/2006/main" xmlns:r="http://schemas.openxmlformats.org/officeDocument/2006/relationships">
   <p:cSld>
     <p:spTree>
@@ -9290,548 +10655,6 @@
                 <a:latin typeface="Microsoft YaHei"/>
               </a:rPr>
               <a:t>• 原因：batch=1 时 FA4（256 个 query）吃不满 GPU，batch 变大后注意力更高效；MoE 也从带宽受限变成算力受限。</a:t>
-            </a:r>
-          </a:p>
-        </p:txBody>
-      </p:sp>
-    </p:spTree>
-  </p:cSld>
-  <p:clrMapOvr>
-    <a:masterClrMapping/>
-  </p:clrMapOvr>
-</p:sld>
-</file>
-
-<file path=ppt/slides/slide9.xml><?xml version="1.0" encoding="utf-8"?>
-<p:sld xmlns:a="http://schemas.openxmlformats.org/drawingml/2006/main" xmlns:p="http://schemas.openxmlformats.org/presentationml/2006/main" xmlns:r="http://schemas.openxmlformats.org/officeDocument/2006/relationships">
-  <p:cSld>
-    <p:spTree>
-      <p:nvGrpSpPr>
-        <p:cNvPr id="1" name=""/>
-        <p:cNvGrpSpPr/>
-        <p:nvPr/>
-      </p:nvGrpSpPr>
-      <p:grpSpPr/>
-      <p:sp>
-        <p:nvSpPr>
-          <p:cNvPr id="2" name="TextBox 1"/>
-          <p:cNvSpPr txBox="1"/>
-          <p:nvPr/>
-        </p:nvSpPr>
-        <p:spPr>
-          <a:xfrm>
-            <a:off x="457200" y="274320"/>
-            <a:ext cx="11247120" cy="640080"/>
-          </a:xfrm>
-          <a:prstGeom prst="rect">
-            <a:avLst/>
-          </a:prstGeom>
-          <a:noFill/>
-        </p:spPr>
-        <p:txBody>
-          <a:bodyPr wrap="square">
-            <a:spAutoFit/>
-          </a:bodyPr>
-          <a:lstStyle/>
-          <a:p>
-            <a:pPr>
-              <a:spcAft>
-                <a:spcPts val="400"/>
-              </a:spcAft>
-            </a:pPr>
-            <a:r>
-              <a:rPr sz="2400" b="1">
-                <a:latin typeface="Microsoft YaHei"/>
-              </a:rPr>
-              <a:t>相关工作与新颖性现状</a:t>
-            </a:r>
-          </a:p>
-        </p:txBody>
-      </p:sp>
-      <p:sp>
-        <p:nvSpPr>
-          <p:cNvPr id="3" name="TextBox 2"/>
-          <p:cNvSpPr txBox="1"/>
-          <p:nvPr/>
-        </p:nvSpPr>
-        <p:spPr>
-          <a:xfrm>
-            <a:off x="457200" y="868680"/>
-            <a:ext cx="11247120" cy="548640"/>
-          </a:xfrm>
-          <a:prstGeom prst="rect">
-            <a:avLst/>
-          </a:prstGeom>
-          <a:noFill/>
-        </p:spPr>
-        <p:txBody>
-          <a:bodyPr wrap="square">
-            <a:spAutoFit/>
-          </a:bodyPr>
-          <a:lstStyle/>
-          <a:p>
-            <a:pPr>
-              <a:spcAft>
-                <a:spcPts val="400"/>
-              </a:spcAft>
-            </a:pPr>
-            <a:r>
-              <a:rPr sz="1200" b="0">
-                <a:solidFill>
-                  <a:srgbClr val="555555"/>
-                </a:solidFill>
-                <a:latin typeface="Microsoft YaHei"/>
-              </a:rPr>
-              <a:t>2026-10-01 复核论文摘要/正文 · 组内工作只引用</a:t>
-            </a:r>
-          </a:p>
-        </p:txBody>
-      </p:sp>
-      <p:graphicFrame>
-        <p:nvGraphicFramePr>
-          <p:cNvPr id="4" name="Table 3"/>
-          <p:cNvGraphicFramePr>
-            <a:graphicFrameLocks noGrp="1"/>
-          </p:cNvGraphicFramePr>
-          <p:nvPr/>
-        </p:nvGraphicFramePr>
-        <p:xfrm>
-          <a:off x="365760" y="1463040"/>
-          <a:ext cx="11430000" cy="2194560"/>
-        </p:xfrm>
-        <a:graphic>
-          <a:graphicData uri="http://schemas.openxmlformats.org/drawingml/2006/table">
-            <a:tbl>
-              <a:tblPr firstRow="1" bandRow="1">
-                <a:tableStyleId>{5C22544A-7EE6-4342-B048-85BDC9FD1C3A}</a:tableStyleId>
-              </a:tblPr>
-              <a:tblGrid>
-                <a:gridCol w="2377440"/>
-                <a:gridCol w="3474720"/>
-                <a:gridCol w="2743200"/>
-                <a:gridCol w="2834640"/>
-              </a:tblGrid>
-              <a:tr h="365760">
-                <a:tc>
-                  <a:txBody>
-                    <a:bodyPr/>
-                    <a:lstStyle/>
-                    <a:p>
-                      <a:r>
-                        <a:rPr sz="1200" b="1">
-                          <a:latin typeface="Microsoft YaHei"/>
-                        </a:rPr>
-                        <a:t>工作</a:t>
-                      </a:r>
-                    </a:p>
-                  </a:txBody>
-                  <a:tcPr/>
-                </a:tc>
-                <a:tc>
-                  <a:txBody>
-                    <a:bodyPr/>
-                    <a:lstStyle/>
-                    <a:p>
-                      <a:r>
-                        <a:rPr sz="1200" b="1">
-                          <a:latin typeface="Microsoft YaHei"/>
-                        </a:rPr>
-                        <a:t>做法</a:t>
-                      </a:r>
-                    </a:p>
-                  </a:txBody>
-                  <a:tcPr/>
-                </a:tc>
-                <a:tc>
-                  <a:txBody>
-                    <a:bodyPr/>
-                    <a:lstStyle/>
-                    <a:p>
-                      <a:r>
-                        <a:rPr sz="1200" b="1">
-                          <a:latin typeface="Microsoft YaHei"/>
-                        </a:rPr>
-                        <a:t>设置</a:t>
-                      </a:r>
-                    </a:p>
-                  </a:txBody>
-                  <a:tcPr/>
-                </a:tc>
-                <a:tc>
-                  <a:txBody>
-                    <a:bodyPr/>
-                    <a:lstStyle/>
-                    <a:p>
-                      <a:r>
-                        <a:rPr sz="1200" b="1">
-                          <a:latin typeface="Microsoft YaHei"/>
-                        </a:rPr>
-                        <a:t>与我们的关系</a:t>
-                      </a:r>
-                    </a:p>
-                  </a:txBody>
-                  <a:tcPr/>
-                </a:tc>
-              </a:tr>
-              <a:tr h="365760">
-                <a:tc>
-                  <a:txBody>
-                    <a:bodyPr/>
-                    <a:lstStyle/>
-                    <a:p>
-                      <a:r>
-                        <a:rPr sz="1200" b="0">
-                          <a:latin typeface="Microsoft YaHei"/>
-                        </a:rPr>
-                        <a:t>SparseD（ICLR 2026）</a:t>
-                      </a:r>
-                    </a:p>
-                  </a:txBody>
-                  <a:tcPr/>
-                </a:tc>
-                <a:tc>
-                  <a:txBody>
-                    <a:bodyPr/>
-                    <a:lstStyle/>
-                    <a:p>
-                      <a:r>
-                        <a:rPr sz="1200" b="0">
-                          <a:latin typeface="Microsoft YaHei"/>
-                        </a:rPr>
-                        <a:t>前若干步 dense，再按池化分数选块并复用</a:t>
-                      </a:r>
-                    </a:p>
-                  </a:txBody>
-                  <a:tcPr/>
-                </a:tc>
-                <a:tc>
-                  <a:txBody>
-                    <a:bodyPr/>
-                    <a:lstStyle/>
-                    <a:p>
-                      <a:r>
-                        <a:rPr sz="1200" b="0">
-                          <a:latin typeface="Microsoft YaHei"/>
-                        </a:rPr>
-                        <a:t>LLaDA/Dream，固定步数</a:t>
-                      </a:r>
-                    </a:p>
-                  </a:txBody>
-                  <a:tcPr/>
-                </a:tc>
-                <a:tc>
-                  <a:txBody>
-                    <a:bodyPr/>
-                    <a:lstStyle/>
-                    <a:p>
-                      <a:r>
-                        <a:rPr sz="1200" b="0">
-                          <a:latin typeface="Microsoft YaHei"/>
-                        </a:rPr>
-                        <a:t>≈ B，撞车；同 kernel 正面对比速度无显著差别</a:t>
-                      </a:r>
-                    </a:p>
-                  </a:txBody>
-                  <a:tcPr/>
-                </a:tc>
-              </a:tr>
-              <a:tr h="365760">
-                <a:tc>
-                  <a:txBody>
-                    <a:bodyPr/>
-                    <a:lstStyle/>
-                    <a:p>
-                      <a:r>
-                        <a:rPr sz="1200" b="0">
-                          <a:latin typeface="Microsoft YaHei"/>
-                        </a:rPr>
-                        <a:t>MAGE（2602.14209）</a:t>
-                      </a:r>
-                    </a:p>
-                  </a:txBody>
-                  <a:tcPr/>
-                </a:tc>
-                <a:tc>
-                  <a:txBody>
-                    <a:bodyPr/>
-                    <a:lstStyle/>
-                    <a:p>
-                      <a:r>
-                        <a:rPr sz="1200" b="0">
-                          <a:latin typeface="Microsoft YaHei"/>
-                        </a:rPr>
-                        <a:t>块的第一步精确注意力选 top-k，整块复用；副流异步</a:t>
-                      </a:r>
-                    </a:p>
-                  </a:txBody>
-                  <a:tcPr/>
-                </a:tc>
-                <a:tc>
-                  <a:txBody>
-                    <a:bodyPr/>
-                    <a:lstStyle/>
-                    <a:p>
-                      <a:r>
-                        <a:rPr sz="1200" b="0">
-                          <a:latin typeface="Microsoft YaHei"/>
-                        </a:rPr>
-                        <a:t>7–8B 块扩散，32 token 块 × 固定 32 步，128K 6.82×</a:t>
-                      </a:r>
-                    </a:p>
-                  </a:txBody>
-                  <a:tcPr/>
-                </a:tc>
-                <a:tc>
-                  <a:txBody>
-                    <a:bodyPr/>
-                    <a:lstStyle/>
-                    <a:p>
-                      <a:r>
-                        <a:rPr sz="1200" b="0">
-                          <a:latin typeface="Microsoft YaHei"/>
-                        </a:rPr>
-                        <a:t>≈ B（撞车）；大倍数来自 dense 小模型 + 128K</a:t>
-                      </a:r>
-                    </a:p>
-                  </a:txBody>
-                  <a:tcPr/>
-                </a:tc>
-              </a:tr>
-              <a:tr h="365760">
-                <a:tc>
-                  <a:txBody>
-                    <a:bodyPr/>
-                    <a:lstStyle/>
-                    <a:p>
-                      <a:r>
-                        <a:rPr sz="1200" b="0">
-                          <a:latin typeface="Microsoft YaHei"/>
-                        </a:rPr>
-                        <a:t>HERALD（2606.21633）</a:t>
-                      </a:r>
-                    </a:p>
-                  </a:txBody>
-                  <a:tcPr/>
-                </a:tc>
-                <a:tc>
-                  <a:txBody>
-                    <a:bodyPr/>
-                    <a:lstStyle/>
-                    <a:p>
-                      <a:r>
-                        <a:rPr sz="1200" b="0">
-                          <a:latin typeface="Microsoft YaHei"/>
-                        </a:rPr>
-                        <a:t>批量块扩散服务：每块选一次 KV，CPU-GPU 协同取 KV</a:t>
-                      </a:r>
-                    </a:p>
-                  </a:txBody>
-                  <a:tcPr/>
-                </a:tc>
-                <a:tc>
-                  <a:txBody>
-                    <a:bodyPr/>
-                    <a:lstStyle/>
-                    <a:p>
-                      <a:r>
-                        <a:rPr sz="1200" b="0">
-                          <a:latin typeface="Microsoft YaHei"/>
-                        </a:rPr>
-                        <a:t>解码吞吐 2.28×，5% KV 预算</a:t>
-                      </a:r>
-                    </a:p>
-                  </a:txBody>
-                  <a:tcPr/>
-                </a:tc>
-                <a:tc>
-                  <a:txBody>
-                    <a:bodyPr/>
-                    <a:lstStyle/>
-                    <a:p>
-                      <a:r>
-                        <a:rPr sz="1200" b="0">
-                          <a:latin typeface="Microsoft YaHei"/>
-                        </a:rPr>
-                        <a:t>批量服务方向的直接相关工作</a:t>
-                      </a:r>
-                    </a:p>
-                  </a:txBody>
-                  <a:tcPr/>
-                </a:tc>
-              </a:tr>
-              <a:tr h="365760">
-                <a:tc>
-                  <a:txBody>
-                    <a:bodyPr/>
-                    <a:lstStyle/>
-                    <a:p>
-                      <a:r>
-                        <a:rPr sz="1200" b="0">
-                          <a:latin typeface="Microsoft YaHei"/>
-                        </a:rPr>
-                        <a:t>PulseCol / Focus-dLLM / LoSA</a:t>
-                      </a:r>
-                    </a:p>
-                  </a:txBody>
-                  <a:tcPr/>
-                </a:tc>
-                <a:tc>
-                  <a:txBody>
-                    <a:bodyPr/>
-                    <a:lstStyle/>
-                    <a:p>
-                      <a:r>
-                        <a:rPr sz="1200" b="0">
-                          <a:latin typeface="Microsoft YaHei"/>
-                        </a:rPr>
-                        <a:t>周期刷新 / 按置信度裁剪 / 稳定 token 复用</a:t>
-                      </a:r>
-                    </a:p>
-                  </a:txBody>
-                  <a:tcPr/>
-                </a:tc>
-                <a:tc>
-                  <a:txBody>
-                    <a:bodyPr/>
-                    <a:lstStyle/>
-                    <a:p>
-                      <a:r>
-                        <a:rPr sz="1200" b="0">
-                          <a:latin typeface="Microsoft YaHei"/>
-                        </a:rPr>
-                        <a:t>固定步数或长度</a:t>
-                      </a:r>
-                    </a:p>
-                  </a:txBody>
-                  <a:tcPr/>
-                </a:tc>
-                <a:tc>
-                  <a:txBody>
-                    <a:bodyPr/>
-                    <a:lstStyle/>
-                    <a:p>
-                      <a:r>
-                        <a:rPr sz="1200" b="0">
-                          <a:latin typeface="Microsoft YaHei"/>
-                        </a:rPr>
-                        <a:t>部分相关</a:t>
-                      </a:r>
-                    </a:p>
-                  </a:txBody>
-                  <a:tcPr/>
-                </a:tc>
-              </a:tr>
-              <a:tr h="365760">
-                <a:tc>
-                  <a:txBody>
-                    <a:bodyPr/>
-                    <a:lstStyle/>
-                    <a:p>
-                      <a:r>
-                        <a:rPr sz="1200" b="0">
-                          <a:latin typeface="Microsoft YaHei"/>
-                        </a:rPr>
-                        <a:t>Lil / LessIsMore</a:t>
-                      </a:r>
-                    </a:p>
-                  </a:txBody>
-                  <a:tcPr/>
-                </a:tc>
-                <a:tc>
-                  <a:txBody>
-                    <a:bodyPr/>
-                    <a:lstStyle/>
-                    <a:p>
-                      <a:r>
-                        <a:rPr sz="1200" b="0">
-                          <a:latin typeface="Microsoft YaHei"/>
-                        </a:rPr>
-                        <a:t>稀疏注意力导致推理输出变长</a:t>
-                      </a:r>
-                    </a:p>
-                  </a:txBody>
-                  <a:tcPr/>
-                </a:tc>
-                <a:tc>
-                  <a:txBody>
-                    <a:bodyPr/>
-                    <a:lstStyle/>
-                    <a:p>
-                      <a:r>
-                        <a:rPr sz="1200" b="0">
-                          <a:latin typeface="Microsoft YaHei"/>
-                        </a:rPr>
-                        <a:t>自回归推理模型</a:t>
-                      </a:r>
-                    </a:p>
-                  </a:txBody>
-                  <a:tcPr/>
-                </a:tc>
-                <a:tc>
-                  <a:txBody>
-                    <a:bodyPr/>
-                    <a:lstStyle/>
-                    <a:p>
-                      <a:r>
-                        <a:rPr sz="1200" b="0">
-                          <a:latin typeface="Microsoft YaHei"/>
-                        </a:rPr>
-                        <a:t>我们在大样本下没有观察到输出变长</a:t>
-                      </a:r>
-                    </a:p>
-                  </a:txBody>
-                  <a:tcPr/>
-                </a:tc>
-              </a:tr>
-            </a:tbl>
-          </a:graphicData>
-        </a:graphic>
-      </p:graphicFrame>
-      <p:sp>
-        <p:nvSpPr>
-          <p:cNvPr id="5" name="TextBox 4"/>
-          <p:cNvSpPr txBox="1"/>
-          <p:nvPr/>
-        </p:nvSpPr>
-        <p:spPr>
-          <a:xfrm>
-            <a:off x="365760" y="3794760"/>
-            <a:ext cx="11430000" cy="2286000"/>
-          </a:xfrm>
-          <a:prstGeom prst="rect">
-            <a:avLst/>
-          </a:prstGeom>
-          <a:noFill/>
-        </p:spPr>
-        <p:txBody>
-          <a:bodyPr wrap="square">
-            <a:spAutoFit/>
-          </a:bodyPr>
-          <a:lstStyle/>
-          <a:p>
-            <a:pPr>
-              <a:spcAft>
-                <a:spcPts val="400"/>
-              </a:spcAft>
-            </a:pPr>
-            <a:r>
-              <a:rPr sz="1400" b="0">
-                <a:latin typeface="Microsoft YaHei"/>
-              </a:rPr>
-              <a:t>• "每块选一次、复用"已被 SparseD / MAGE / HERALD 覆盖；"看 V 的选块更好"没有数据支持（E8：AIME 70% 稀疏度下无 V 项优于只看注意力质量）；64K 对照 E9 待出。</a:t>
-            </a:r>
-          </a:p>
-          <a:p>
-            <a:pPr>
-              <a:spcAft>
-                <a:spcPts val="400"/>
-              </a:spcAft>
-            </a:pPr>
-            <a:r>
-              <a:rPr sz="1400" b="0">
-                <a:latin typeface="Microsoft YaHei"/>
-              </a:rPr>
-              <a:t>• 站得住的：生产级 MoE dLLM + 原生自适应停止 + 最强官方基线 + 大样本协议下的端到端收益与精度，以及成本结构分析。</a:t>
             </a:r>
           </a:p>
         </p:txBody>

</xml_diff>